<commit_message>
Show full pool, buffer, VCU and per-price credit values on carbon slide
Co-Authored-By: Claude Opus 5.5 <noreply@anthropic.com>
Claude-Session: https://claude.ai/code/session_01HX5nFh84sXAe67hTHVd9UH
</commit_message>
<xml_diff>
--- a/Potensi_Kredit_Karbon_LPHD.pptx
+++ b/Potensi_Kredit_Karbon_LPHD.pptx
@@ -133,7 +133,7 @@
                 </a:solidFill>
                 <a:latin typeface="+mn-lt"/>
               </a:rPr>
-              <a:t>Nilai kredit per skenario harga, Rp miliar</a:t>
+              <a:t>Potensi kredit karbon per skenario harga, Rp miliar</a:t>
             </a:r>
           </a:p>
         </c:rich>
@@ -176,7 +176,7 @@
               <a:lstStyle/>
               <a:p>
                 <a:pPr>
-                  <a:defRPr b="0" i="0" strike="noStrike" sz="1300" u="none">
+                  <a:defRPr b="0" i="0" strike="noStrike" sz="1200" u="none">
                     <a:solidFill>
                       <a:srgbClr val="1B2420"/>
                     </a:solidFill>
@@ -265,7 +265,7 @@
               <a:lstStyle/>
               <a:p>
                 <a:pPr>
-                  <a:defRPr b="0" i="0" strike="noStrike" sz="1300" u="none">
+                  <a:defRPr b="0" i="0" strike="noStrike" sz="1200" u="none">
                     <a:solidFill>
                       <a:srgbClr val="1B2420"/>
                     </a:solidFill>
@@ -333,7 +333,7 @@
             <a:lstStyle/>
             <a:p>
               <a:pPr>
-                <a:defRPr b="0" i="0" strike="noStrike" sz="1300" u="none">
+                <a:defRPr b="0" i="0" strike="noStrike" sz="1200" u="none">
                   <a:solidFill>
                     <a:srgbClr val="1B2420"/>
                   </a:solidFill>
@@ -381,7 +381,7 @@
           <a:lstStyle/>
           <a:p>
             <a:pPr>
-              <a:defRPr sz="1300" b="0" i="0" u="none" strike="noStrike">
+              <a:defRPr sz="1200" b="0" i="0" u="none" strike="noStrike">
                 <a:solidFill>
                   <a:srgbClr val="5F6B65"/>
                 </a:solidFill>
@@ -401,7 +401,7 @@
         <c:axId val="2094734552"/>
         <c:scaling>
           <c:orientation val="minMax"/>
-          <c:max val="400"/>
+          <c:max val="420"/>
           <c:min val="0"/>
         </c:scaling>
         <c:delete val="1"/>
@@ -454,7 +454,7 @@
         <a:lstStyle/>
         <a:p>
           <a:pPr>
-            <a:defRPr sz="1200">
+            <a:defRPr sz="1100">
               <a:solidFill>
                 <a:srgbClr val="5F6B65"/>
               </a:solidFill>
@@ -1434,7 +1434,7 @@
                 <a:ea typeface="Cambria" pitchFamily="34" charset="-122"/>
                 <a:cs typeface="Cambria" pitchFamily="34" charset="-120"/>
               </a:rPr>
-              <a:t>Porsi LPHD 5.884 VCU bernilai Rp 0,53–2,12 miliar, tergantung harga karbon 5–20 USD</a:t>
+              <a:t>Porsi LPHD 5.884 VCU bernilai Rp 0,53–2,12 miliar pada harga karbon 5–20 USD per VCU</a:t>
             </a:r>
             <a:endParaRPr lang="en-US" sz="2800" dirty="0"/>
           </a:p>
@@ -1448,8 +1448,8 @@
         </p:nvSpPr>
         <p:spPr>
           <a:xfrm>
-            <a:off x="548640" y="1920240"/>
-            <a:ext cx="3931920" cy="1234440"/>
+            <a:off x="548640" y="1874520"/>
+            <a:ext cx="5029200" cy="274320"/>
           </a:xfrm>
           <a:prstGeom prst="rect">
             <a:avLst/>
@@ -1465,44 +1465,1455 @@
               <a:buNone/>
             </a:pPr>
             <a:r>
-              <a:rPr lang="en-US" sz="5400" b="1" dirty="0">
+              <a:rPr lang="en-US" sz="1300" b="1" dirty="0">
                 <a:solidFill>
-                  <a:schemeClr val="accent1"/>
-                </a:solidFill>
-                <a:latin typeface="Cambria" pitchFamily="34" charset="0"/>
-                <a:ea typeface="Cambria" pitchFamily="34" charset="-122"/>
-                <a:cs typeface="Cambria" pitchFamily="34" charset="-120"/>
-              </a:rPr>
-              <a:t>5.884</a:t>
-            </a:r>
-            <a:endParaRPr lang="en-US" sz="1400" dirty="0"/>
-          </a:p>
-          <a:p>
-            <a:pPr indent="0" marL="0">
-              <a:buNone/>
-            </a:pPr>
-            <a:r>
-              <a:rPr lang="en-US" sz="1500" b="1" dirty="0">
-                <a:solidFill>
-                  <a:schemeClr val="tx1"/>
+                  <a:schemeClr val="accent4"/>
                 </a:solidFill>
               </a:rPr>
-              <a:t>VCU porsi LPHD (60%)</a:t>
+              <a:t>Stok karbon dan kredit</a:t>
             </a:r>
-            <a:endParaRPr lang="en-US" sz="1400" dirty="0"/>
+            <a:endParaRPr lang="en-US" sz="1300" dirty="0"/>
           </a:p>
         </p:txBody>
       </p:sp>
+      <p:graphicFrame>
+        <p:nvGraphicFramePr>
+          <p:cNvPr id="2" name="tabel-stok"/>
+          <p:cNvGraphicFramePr>
+            <a:graphicFrameLocks noGrp="1"/>
+          </p:cNvGraphicFramePr>
+          <p:nvPr>
+            <p:extLst>
+              <p:ext uri="{D42A27DB-BD31-4B8C-83A1-F6EECF244321}">
+                <p14:modId xmlns:p14="http://schemas.microsoft.com/office/powerpoint/2010/main" val="1579011935"/>
+              </p:ext>
+            </p:extLst>
+          </p:nvPr>
+        </p:nvGraphicFramePr>
+        <p:xfrm>
+          <a:off x="548640" y="2194560"/>
+          <a:ext cx="5029200" cy="914400"/>
+        </p:xfrm>
+        <a:graphic>
+          <a:graphicData uri="http://schemas.openxmlformats.org/drawingml/2006/table">
+            <a:tbl>
+              <a:tblPr/>
+              <a:tblGrid>
+                <a:gridCol w="1920240"/>
+                <a:gridCol w="1463040"/>
+                <a:gridCol w="1645920"/>
+              </a:tblGrid>
+              <a:tr h="292608">
+                <a:tc>
+                  <a:txBody>
+                    <a:bodyPr/>
+                    <a:lstStyle/>
+                    <a:p>
+                      <a:pPr algn="l" indent="0" marL="0">
+                        <a:buNone/>
+                      </a:pPr>
+                      <a:r>
+                        <a:rPr lang="en-US" sz="1200" b="1" dirty="0">
+                          <a:solidFill>
+                            <a:srgbClr val="5F6B65"/>
+                          </a:solidFill>
+                          <a:latin typeface="Calibri" pitchFamily="34" charset="0"/>
+                          <a:ea typeface="Calibri" pitchFamily="34" charset="-122"/>
+                          <a:cs typeface="Calibri" pitchFamily="34" charset="-120"/>
+                        </a:rPr>
+                        <a:t>Pool</a:t>
+                      </a:r>
+                      <a:endParaRPr lang="en-US" sz="1200" dirty="0">
+                        <a:latin typeface="Calibri" charset="0"/>
+                        <a:ea typeface="Calibri" charset="0"/>
+                        <a:cs typeface="Calibri" charset="0"/>
+                      </a:endParaRPr>
+                    </a:p>
+                  </a:txBody>
+                  <a:tcPr marL="73152" marR="73152" marT="18288" marB="18288" anchor="ctr">
+                    <a:lnL w="0" cap="flat" cmpd="sng" algn="ctr">
+                      <a:noFill/>
+                    </a:lnL>
+                    <a:lnR w="0" cap="flat" cmpd="sng" algn="ctr">
+                      <a:noFill/>
+                    </a:lnR>
+                    <a:lnT w="0" cap="flat" cmpd="sng" algn="ctr">
+                      <a:noFill/>
+                    </a:lnT>
+                    <a:lnB w="12700" cap="flat" cmpd="sng" algn="ctr">
+                      <a:solidFill>
+                        <a:srgbClr val="D5DBD6"/>
+                      </a:solidFill>
+                      <a:prstDash val="solid"/>
+                      <a:round/>
+                      <a:headEnd type="none" w="med" len="med"/>
+                      <a:tailEnd type="none" w="med" len="med"/>
+                    </a:lnB>
+                  </a:tcPr>
+                </a:tc>
+                <a:tc>
+                  <a:txBody>
+                    <a:bodyPr/>
+                    <a:lstStyle/>
+                    <a:p>
+                      <a:pPr algn="r" indent="0" marL="0">
+                        <a:buNone/>
+                      </a:pPr>
+                      <a:r>
+                        <a:rPr lang="en-US" sz="1200" b="1" dirty="0">
+                          <a:solidFill>
+                            <a:srgbClr val="5F6B65"/>
+                          </a:solidFill>
+                          <a:latin typeface="Calibri" pitchFamily="34" charset="0"/>
+                          <a:ea typeface="Calibri" pitchFamily="34" charset="-122"/>
+                          <a:cs typeface="Calibri" pitchFamily="34" charset="-120"/>
+                        </a:rPr>
+                        <a:t>Ton karbon</a:t>
+                      </a:r>
+                      <a:endParaRPr lang="en-US" sz="1200" dirty="0">
+                        <a:latin typeface="Calibri" charset="0"/>
+                        <a:ea typeface="Calibri" charset="0"/>
+                        <a:cs typeface="Calibri" charset="0"/>
+                      </a:endParaRPr>
+                    </a:p>
+                  </a:txBody>
+                  <a:tcPr marL="73152" marR="73152" marT="18288" marB="18288" anchor="ctr">
+                    <a:lnL w="0" cap="flat" cmpd="sng" algn="ctr">
+                      <a:noFill/>
+                    </a:lnL>
+                    <a:lnR w="0" cap="flat" cmpd="sng" algn="ctr">
+                      <a:noFill/>
+                    </a:lnR>
+                    <a:lnT w="0" cap="flat" cmpd="sng" algn="ctr">
+                      <a:noFill/>
+                    </a:lnT>
+                    <a:lnB w="12700" cap="flat" cmpd="sng" algn="ctr">
+                      <a:solidFill>
+                        <a:srgbClr val="D5DBD6"/>
+                      </a:solidFill>
+                      <a:prstDash val="solid"/>
+                      <a:round/>
+                      <a:headEnd type="none" w="med" len="med"/>
+                      <a:tailEnd type="none" w="med" len="med"/>
+                    </a:lnB>
+                  </a:tcPr>
+                </a:tc>
+                <a:tc>
+                  <a:txBody>
+                    <a:bodyPr/>
+                    <a:lstStyle/>
+                    <a:p>
+                      <a:pPr algn="r" indent="0" marL="0">
+                        <a:buNone/>
+                      </a:pPr>
+                      <a:r>
+                        <a:rPr lang="en-US" sz="1200" b="1" dirty="0">
+                          <a:solidFill>
+                            <a:srgbClr val="5F6B65"/>
+                          </a:solidFill>
+                          <a:latin typeface="Calibri" pitchFamily="34" charset="0"/>
+                          <a:ea typeface="Calibri" pitchFamily="34" charset="-122"/>
+                          <a:cs typeface="Calibri" pitchFamily="34" charset="-120"/>
+                        </a:rPr>
+                        <a:t>Ton CO₂e</a:t>
+                      </a:r>
+                      <a:endParaRPr lang="en-US" sz="1200" dirty="0">
+                        <a:latin typeface="Calibri" charset="0"/>
+                        <a:ea typeface="Calibri" charset="0"/>
+                        <a:cs typeface="Calibri" charset="0"/>
+                      </a:endParaRPr>
+                    </a:p>
+                  </a:txBody>
+                  <a:tcPr marL="73152" marR="73152" marT="18288" marB="18288" anchor="ctr">
+                    <a:lnL w="0" cap="flat" cmpd="sng" algn="ctr">
+                      <a:noFill/>
+                    </a:lnL>
+                    <a:lnR w="0" cap="flat" cmpd="sng" algn="ctr">
+                      <a:noFill/>
+                    </a:lnR>
+                    <a:lnT w="0" cap="flat" cmpd="sng" algn="ctr">
+                      <a:noFill/>
+                    </a:lnT>
+                    <a:lnB w="12700" cap="flat" cmpd="sng" algn="ctr">
+                      <a:solidFill>
+                        <a:srgbClr val="D5DBD6"/>
+                      </a:solidFill>
+                      <a:prstDash val="solid"/>
+                      <a:round/>
+                      <a:headEnd type="none" w="med" len="med"/>
+                      <a:tailEnd type="none" w="med" len="med"/>
+                    </a:lnB>
+                  </a:tcPr>
+                </a:tc>
+              </a:tr>
+              <a:tr h="292608">
+                <a:tc>
+                  <a:txBody>
+                    <a:bodyPr/>
+                    <a:lstStyle/>
+                    <a:p>
+                      <a:pPr algn="l" indent="0" marL="0">
+                        <a:buNone/>
+                      </a:pPr>
+                      <a:r>
+                        <a:rPr lang="en-US" sz="1200" dirty="0">
+                          <a:solidFill>
+                            <a:srgbClr val="1B2420"/>
+                          </a:solidFill>
+                          <a:latin typeface="Calibri" pitchFamily="34" charset="0"/>
+                          <a:ea typeface="Calibri" pitchFamily="34" charset="-122"/>
+                          <a:cs typeface="Calibri" pitchFamily="34" charset="-120"/>
+                        </a:rPr>
+                        <a:t>AGB</a:t>
+                      </a:r>
+                      <a:endParaRPr lang="en-US" sz="1200" dirty="0">
+                        <a:latin typeface="Calibri" charset="0"/>
+                        <a:ea typeface="Calibri" charset="0"/>
+                        <a:cs typeface="Calibri" charset="0"/>
+                      </a:endParaRPr>
+                    </a:p>
+                  </a:txBody>
+                  <a:tcPr marL="73152" marR="73152" marT="18288" marB="18288" anchor="ctr">
+                    <a:lnL w="0" cap="flat" cmpd="sng" algn="ctr">
+                      <a:noFill/>
+                    </a:lnL>
+                    <a:lnR w="0" cap="flat" cmpd="sng" algn="ctr">
+                      <a:noFill/>
+                    </a:lnR>
+                    <a:lnT w="0" cap="flat" cmpd="sng" algn="ctr">
+                      <a:noFill/>
+                    </a:lnT>
+                    <a:lnB w="9525" cap="flat" cmpd="sng" algn="ctr">
+                      <a:solidFill>
+                        <a:srgbClr val="D5DBD6"/>
+                      </a:solidFill>
+                      <a:prstDash val="solid"/>
+                      <a:round/>
+                      <a:headEnd type="none" w="med" len="med"/>
+                      <a:tailEnd type="none" w="med" len="med"/>
+                    </a:lnB>
+                  </a:tcPr>
+                </a:tc>
+                <a:tc>
+                  <a:txBody>
+                    <a:bodyPr/>
+                    <a:lstStyle/>
+                    <a:p>
+                      <a:pPr algn="r" indent="0" marL="0">
+                        <a:buNone/>
+                      </a:pPr>
+                      <a:r>
+                        <a:rPr lang="en-US" sz="1200" dirty="0">
+                          <a:solidFill>
+                            <a:srgbClr val="1B2420"/>
+                          </a:solidFill>
+                          <a:latin typeface="Calibri" pitchFamily="34" charset="0"/>
+                          <a:ea typeface="Calibri" pitchFamily="34" charset="-122"/>
+                          <a:cs typeface="Calibri" pitchFamily="34" charset="-120"/>
+                        </a:rPr>
+                        <a:t>10.477</a:t>
+                      </a:r>
+                      <a:endParaRPr lang="en-US" sz="1200" dirty="0">
+                        <a:latin typeface="Calibri" charset="0"/>
+                        <a:ea typeface="Calibri" charset="0"/>
+                        <a:cs typeface="Calibri" charset="0"/>
+                      </a:endParaRPr>
+                    </a:p>
+                  </a:txBody>
+                  <a:tcPr marL="73152" marR="73152" marT="18288" marB="18288" anchor="ctr">
+                    <a:lnL w="0" cap="flat" cmpd="sng" algn="ctr">
+                      <a:noFill/>
+                    </a:lnL>
+                    <a:lnR w="0" cap="flat" cmpd="sng" algn="ctr">
+                      <a:noFill/>
+                    </a:lnR>
+                    <a:lnT w="0" cap="flat" cmpd="sng" algn="ctr">
+                      <a:noFill/>
+                    </a:lnT>
+                    <a:lnB w="9525" cap="flat" cmpd="sng" algn="ctr">
+                      <a:solidFill>
+                        <a:srgbClr val="D5DBD6"/>
+                      </a:solidFill>
+                      <a:prstDash val="solid"/>
+                      <a:round/>
+                      <a:headEnd type="none" w="med" len="med"/>
+                      <a:tailEnd type="none" w="med" len="med"/>
+                    </a:lnB>
+                  </a:tcPr>
+                </a:tc>
+                <a:tc>
+                  <a:txBody>
+                    <a:bodyPr/>
+                    <a:lstStyle/>
+                    <a:p>
+                      <a:pPr algn="r" indent="0" marL="0">
+                        <a:buNone/>
+                      </a:pPr>
+                      <a:r>
+                        <a:rPr lang="en-US" sz="1200" dirty="0">
+                          <a:solidFill>
+                            <a:srgbClr val="1B2420"/>
+                          </a:solidFill>
+                          <a:latin typeface="Calibri" pitchFamily="34" charset="0"/>
+                          <a:ea typeface="Calibri" pitchFamily="34" charset="-122"/>
+                          <a:cs typeface="Calibri" pitchFamily="34" charset="-120"/>
+                        </a:rPr>
+                        <a:t>38.415</a:t>
+                      </a:r>
+                      <a:endParaRPr lang="en-US" sz="1200" dirty="0">
+                        <a:latin typeface="Calibri" charset="0"/>
+                        <a:ea typeface="Calibri" charset="0"/>
+                        <a:cs typeface="Calibri" charset="0"/>
+                      </a:endParaRPr>
+                    </a:p>
+                  </a:txBody>
+                  <a:tcPr marL="73152" marR="73152" marT="18288" marB="18288" anchor="ctr">
+                    <a:lnL w="0" cap="flat" cmpd="sng" algn="ctr">
+                      <a:noFill/>
+                    </a:lnL>
+                    <a:lnR w="0" cap="flat" cmpd="sng" algn="ctr">
+                      <a:noFill/>
+                    </a:lnR>
+                    <a:lnT w="0" cap="flat" cmpd="sng" algn="ctr">
+                      <a:noFill/>
+                    </a:lnT>
+                    <a:lnB w="9525" cap="flat" cmpd="sng" algn="ctr">
+                      <a:solidFill>
+                        <a:srgbClr val="D5DBD6"/>
+                      </a:solidFill>
+                      <a:prstDash val="solid"/>
+                      <a:round/>
+                      <a:headEnd type="none" w="med" len="med"/>
+                      <a:tailEnd type="none" w="med" len="med"/>
+                    </a:lnB>
+                  </a:tcPr>
+                </a:tc>
+              </a:tr>
+              <a:tr h="292608">
+                <a:tc>
+                  <a:txBody>
+                    <a:bodyPr/>
+                    <a:lstStyle/>
+                    <a:p>
+                      <a:pPr algn="l" indent="0" marL="0">
+                        <a:buNone/>
+                      </a:pPr>
+                      <a:r>
+                        <a:rPr lang="en-US" sz="1200" dirty="0">
+                          <a:solidFill>
+                            <a:srgbClr val="1B2420"/>
+                          </a:solidFill>
+                          <a:latin typeface="Calibri" pitchFamily="34" charset="0"/>
+                          <a:ea typeface="Calibri" pitchFamily="34" charset="-122"/>
+                          <a:cs typeface="Calibri" pitchFamily="34" charset="-120"/>
+                        </a:rPr>
+                        <a:t>BGB</a:t>
+                      </a:r>
+                      <a:endParaRPr lang="en-US" sz="1200" dirty="0">
+                        <a:latin typeface="Calibri" charset="0"/>
+                        <a:ea typeface="Calibri" charset="0"/>
+                        <a:cs typeface="Calibri" charset="0"/>
+                      </a:endParaRPr>
+                    </a:p>
+                  </a:txBody>
+                  <a:tcPr marL="73152" marR="73152" marT="18288" marB="18288" anchor="ctr">
+                    <a:lnL w="0" cap="flat" cmpd="sng" algn="ctr">
+                      <a:noFill/>
+                    </a:lnL>
+                    <a:lnR w="0" cap="flat" cmpd="sng" algn="ctr">
+                      <a:noFill/>
+                    </a:lnR>
+                    <a:lnT w="0" cap="flat" cmpd="sng" algn="ctr">
+                      <a:noFill/>
+                    </a:lnT>
+                    <a:lnB w="9525" cap="flat" cmpd="sng" algn="ctr">
+                      <a:solidFill>
+                        <a:srgbClr val="D5DBD6"/>
+                      </a:solidFill>
+                      <a:prstDash val="solid"/>
+                      <a:round/>
+                      <a:headEnd type="none" w="med" len="med"/>
+                      <a:tailEnd type="none" w="med" len="med"/>
+                    </a:lnB>
+                  </a:tcPr>
+                </a:tc>
+                <a:tc>
+                  <a:txBody>
+                    <a:bodyPr/>
+                    <a:lstStyle/>
+                    <a:p>
+                      <a:pPr algn="r" indent="0" marL="0">
+                        <a:buNone/>
+                      </a:pPr>
+                      <a:r>
+                        <a:rPr lang="en-US" sz="1200" dirty="0">
+                          <a:solidFill>
+                            <a:srgbClr val="1B2420"/>
+                          </a:solidFill>
+                          <a:latin typeface="Calibri" pitchFamily="34" charset="0"/>
+                          <a:ea typeface="Calibri" pitchFamily="34" charset="-122"/>
+                          <a:cs typeface="Calibri" pitchFamily="34" charset="-120"/>
+                        </a:rPr>
+                        <a:t>30</a:t>
+                      </a:r>
+                      <a:endParaRPr lang="en-US" sz="1200" dirty="0">
+                        <a:latin typeface="Calibri" charset="0"/>
+                        <a:ea typeface="Calibri" charset="0"/>
+                        <a:cs typeface="Calibri" charset="0"/>
+                      </a:endParaRPr>
+                    </a:p>
+                  </a:txBody>
+                  <a:tcPr marL="73152" marR="73152" marT="18288" marB="18288" anchor="ctr">
+                    <a:lnL w="0" cap="flat" cmpd="sng" algn="ctr">
+                      <a:noFill/>
+                    </a:lnL>
+                    <a:lnR w="0" cap="flat" cmpd="sng" algn="ctr">
+                      <a:noFill/>
+                    </a:lnR>
+                    <a:lnT w="0" cap="flat" cmpd="sng" algn="ctr">
+                      <a:noFill/>
+                    </a:lnT>
+                    <a:lnB w="9525" cap="flat" cmpd="sng" algn="ctr">
+                      <a:solidFill>
+                        <a:srgbClr val="D5DBD6"/>
+                      </a:solidFill>
+                      <a:prstDash val="solid"/>
+                      <a:round/>
+                      <a:headEnd type="none" w="med" len="med"/>
+                      <a:tailEnd type="none" w="med" len="med"/>
+                    </a:lnB>
+                  </a:tcPr>
+                </a:tc>
+                <a:tc>
+                  <a:txBody>
+                    <a:bodyPr/>
+                    <a:lstStyle/>
+                    <a:p>
+                      <a:pPr algn="r" indent="0" marL="0">
+                        <a:buNone/>
+                      </a:pPr>
+                      <a:r>
+                        <a:rPr lang="en-US" sz="1200" dirty="0">
+                          <a:solidFill>
+                            <a:srgbClr val="1B2420"/>
+                          </a:solidFill>
+                          <a:latin typeface="Calibri" pitchFamily="34" charset="0"/>
+                          <a:ea typeface="Calibri" pitchFamily="34" charset="-122"/>
+                          <a:cs typeface="Calibri" pitchFamily="34" charset="-120"/>
+                        </a:rPr>
+                        <a:t>111</a:t>
+                      </a:r>
+                      <a:endParaRPr lang="en-US" sz="1200" dirty="0">
+                        <a:latin typeface="Calibri" charset="0"/>
+                        <a:ea typeface="Calibri" charset="0"/>
+                        <a:cs typeface="Calibri" charset="0"/>
+                      </a:endParaRPr>
+                    </a:p>
+                  </a:txBody>
+                  <a:tcPr marL="73152" marR="73152" marT="18288" marB="18288" anchor="ctr">
+                    <a:lnL w="0" cap="flat" cmpd="sng" algn="ctr">
+                      <a:noFill/>
+                    </a:lnL>
+                    <a:lnR w="0" cap="flat" cmpd="sng" algn="ctr">
+                      <a:noFill/>
+                    </a:lnR>
+                    <a:lnT w="0" cap="flat" cmpd="sng" algn="ctr">
+                      <a:noFill/>
+                    </a:lnT>
+                    <a:lnB w="9525" cap="flat" cmpd="sng" algn="ctr">
+                      <a:solidFill>
+                        <a:srgbClr val="D5DBD6"/>
+                      </a:solidFill>
+                      <a:prstDash val="solid"/>
+                      <a:round/>
+                      <a:headEnd type="none" w="med" len="med"/>
+                      <a:tailEnd type="none" w="med" len="med"/>
+                    </a:lnB>
+                  </a:tcPr>
+                </a:tc>
+              </a:tr>
+              <a:tr h="292608">
+                <a:tc>
+                  <a:txBody>
+                    <a:bodyPr/>
+                    <a:lstStyle/>
+                    <a:p>
+                      <a:pPr algn="l" indent="0" marL="0">
+                        <a:buNone/>
+                      </a:pPr>
+                      <a:r>
+                        <a:rPr lang="en-US" sz="1200" dirty="0">
+                          <a:solidFill>
+                            <a:srgbClr val="1B2420"/>
+                          </a:solidFill>
+                          <a:latin typeface="Calibri" pitchFamily="34" charset="0"/>
+                          <a:ea typeface="Calibri" pitchFamily="34" charset="-122"/>
+                          <a:cs typeface="Calibri" pitchFamily="34" charset="-120"/>
+                        </a:rPr>
+                        <a:t>Litter</a:t>
+                      </a:r>
+                      <a:endParaRPr lang="en-US" sz="1200" dirty="0">
+                        <a:latin typeface="Calibri" charset="0"/>
+                        <a:ea typeface="Calibri" charset="0"/>
+                        <a:cs typeface="Calibri" charset="0"/>
+                      </a:endParaRPr>
+                    </a:p>
+                  </a:txBody>
+                  <a:tcPr marL="73152" marR="73152" marT="18288" marB="18288" anchor="ctr">
+                    <a:lnL w="0" cap="flat" cmpd="sng" algn="ctr">
+                      <a:noFill/>
+                    </a:lnL>
+                    <a:lnR w="0" cap="flat" cmpd="sng" algn="ctr">
+                      <a:noFill/>
+                    </a:lnR>
+                    <a:lnT w="0" cap="flat" cmpd="sng" algn="ctr">
+                      <a:noFill/>
+                    </a:lnT>
+                    <a:lnB w="9525" cap="flat" cmpd="sng" algn="ctr">
+                      <a:solidFill>
+                        <a:srgbClr val="D5DBD6"/>
+                      </a:solidFill>
+                      <a:prstDash val="solid"/>
+                      <a:round/>
+                      <a:headEnd type="none" w="med" len="med"/>
+                      <a:tailEnd type="none" w="med" len="med"/>
+                    </a:lnB>
+                  </a:tcPr>
+                </a:tc>
+                <a:tc>
+                  <a:txBody>
+                    <a:bodyPr/>
+                    <a:lstStyle/>
+                    <a:p>
+                      <a:pPr algn="r" indent="0" marL="0">
+                        <a:buNone/>
+                      </a:pPr>
+                      <a:r>
+                        <a:rPr lang="en-US" sz="1200" dirty="0">
+                          <a:solidFill>
+                            <a:srgbClr val="1B2420"/>
+                          </a:solidFill>
+                          <a:latin typeface="Calibri" pitchFamily="34" charset="0"/>
+                          <a:ea typeface="Calibri" pitchFamily="34" charset="-122"/>
+                          <a:cs typeface="Calibri" pitchFamily="34" charset="-120"/>
+                        </a:rPr>
+                        <a:t>314</a:t>
+                      </a:r>
+                      <a:endParaRPr lang="en-US" sz="1200" dirty="0">
+                        <a:latin typeface="Calibri" charset="0"/>
+                        <a:ea typeface="Calibri" charset="0"/>
+                        <a:cs typeface="Calibri" charset="0"/>
+                      </a:endParaRPr>
+                    </a:p>
+                  </a:txBody>
+                  <a:tcPr marL="73152" marR="73152" marT="18288" marB="18288" anchor="ctr">
+                    <a:lnL w="0" cap="flat" cmpd="sng" algn="ctr">
+                      <a:noFill/>
+                    </a:lnL>
+                    <a:lnR w="0" cap="flat" cmpd="sng" algn="ctr">
+                      <a:noFill/>
+                    </a:lnR>
+                    <a:lnT w="0" cap="flat" cmpd="sng" algn="ctr">
+                      <a:noFill/>
+                    </a:lnT>
+                    <a:lnB w="9525" cap="flat" cmpd="sng" algn="ctr">
+                      <a:solidFill>
+                        <a:srgbClr val="D5DBD6"/>
+                      </a:solidFill>
+                      <a:prstDash val="solid"/>
+                      <a:round/>
+                      <a:headEnd type="none" w="med" len="med"/>
+                      <a:tailEnd type="none" w="med" len="med"/>
+                    </a:lnB>
+                  </a:tcPr>
+                </a:tc>
+                <a:tc>
+                  <a:txBody>
+                    <a:bodyPr/>
+                    <a:lstStyle/>
+                    <a:p>
+                      <a:pPr algn="r" indent="0" marL="0">
+                        <a:buNone/>
+                      </a:pPr>
+                      <a:r>
+                        <a:rPr lang="en-US" sz="1200" dirty="0">
+                          <a:solidFill>
+                            <a:srgbClr val="1B2420"/>
+                          </a:solidFill>
+                          <a:latin typeface="Calibri" pitchFamily="34" charset="0"/>
+                          <a:ea typeface="Calibri" pitchFamily="34" charset="-122"/>
+                          <a:cs typeface="Calibri" pitchFamily="34" charset="-120"/>
+                        </a:rPr>
+                        <a:t>1.152</a:t>
+                      </a:r>
+                      <a:endParaRPr lang="en-US" sz="1200" dirty="0">
+                        <a:latin typeface="Calibri" charset="0"/>
+                        <a:ea typeface="Calibri" charset="0"/>
+                        <a:cs typeface="Calibri" charset="0"/>
+                      </a:endParaRPr>
+                    </a:p>
+                  </a:txBody>
+                  <a:tcPr marL="73152" marR="73152" marT="18288" marB="18288" anchor="ctr">
+                    <a:lnL w="0" cap="flat" cmpd="sng" algn="ctr">
+                      <a:noFill/>
+                    </a:lnL>
+                    <a:lnR w="0" cap="flat" cmpd="sng" algn="ctr">
+                      <a:noFill/>
+                    </a:lnR>
+                    <a:lnT w="0" cap="flat" cmpd="sng" algn="ctr">
+                      <a:noFill/>
+                    </a:lnT>
+                    <a:lnB w="9525" cap="flat" cmpd="sng" algn="ctr">
+                      <a:solidFill>
+                        <a:srgbClr val="D5DBD6"/>
+                      </a:solidFill>
+                      <a:prstDash val="solid"/>
+                      <a:round/>
+                      <a:headEnd type="none" w="med" len="med"/>
+                      <a:tailEnd type="none" w="med" len="med"/>
+                    </a:lnB>
+                  </a:tcPr>
+                </a:tc>
+              </a:tr>
+              <a:tr h="292608">
+                <a:tc>
+                  <a:txBody>
+                    <a:bodyPr/>
+                    <a:lstStyle/>
+                    <a:p>
+                      <a:pPr algn="l" indent="0" marL="0">
+                        <a:buNone/>
+                      </a:pPr>
+                      <a:r>
+                        <a:rPr lang="en-US" sz="1200" dirty="0">
+                          <a:solidFill>
+                            <a:srgbClr val="1B2420"/>
+                          </a:solidFill>
+                          <a:latin typeface="Calibri" pitchFamily="34" charset="0"/>
+                          <a:ea typeface="Calibri" pitchFamily="34" charset="-122"/>
+                          <a:cs typeface="Calibri" pitchFamily="34" charset="-120"/>
+                        </a:rPr>
+                        <a:t>Soil</a:t>
+                      </a:r>
+                      <a:endParaRPr lang="en-US" sz="1200" dirty="0">
+                        <a:latin typeface="Calibri" charset="0"/>
+                        <a:ea typeface="Calibri" charset="0"/>
+                        <a:cs typeface="Calibri" charset="0"/>
+                      </a:endParaRPr>
+                    </a:p>
+                  </a:txBody>
+                  <a:tcPr marL="73152" marR="73152" marT="18288" marB="18288" anchor="ctr">
+                    <a:lnL w="0" cap="flat" cmpd="sng" algn="ctr">
+                      <a:noFill/>
+                    </a:lnL>
+                    <a:lnR w="0" cap="flat" cmpd="sng" algn="ctr">
+                      <a:noFill/>
+                    </a:lnR>
+                    <a:lnT w="0" cap="flat" cmpd="sng" algn="ctr">
+                      <a:noFill/>
+                    </a:lnT>
+                    <a:lnB w="9525" cap="flat" cmpd="sng" algn="ctr">
+                      <a:solidFill>
+                        <a:srgbClr val="D5DBD6"/>
+                      </a:solidFill>
+                      <a:prstDash val="solid"/>
+                      <a:round/>
+                      <a:headEnd type="none" w="med" len="med"/>
+                      <a:tailEnd type="none" w="med" len="med"/>
+                    </a:lnB>
+                  </a:tcPr>
+                </a:tc>
+                <a:tc>
+                  <a:txBody>
+                    <a:bodyPr/>
+                    <a:lstStyle/>
+                    <a:p>
+                      <a:pPr algn="r" indent="0" marL="0">
+                        <a:buNone/>
+                      </a:pPr>
+                      <a:r>
+                        <a:rPr lang="en-US" sz="1200" dirty="0">
+                          <a:solidFill>
+                            <a:srgbClr val="1B2420"/>
+                          </a:solidFill>
+                          <a:latin typeface="Calibri" pitchFamily="34" charset="0"/>
+                          <a:ea typeface="Calibri" pitchFamily="34" charset="-122"/>
+                          <a:cs typeface="Calibri" pitchFamily="34" charset="-120"/>
+                        </a:rPr>
+                        <a:t>92.387</a:t>
+                      </a:r>
+                      <a:endParaRPr lang="en-US" sz="1200" dirty="0">
+                        <a:latin typeface="Calibri" charset="0"/>
+                        <a:ea typeface="Calibri" charset="0"/>
+                        <a:cs typeface="Calibri" charset="0"/>
+                      </a:endParaRPr>
+                    </a:p>
+                  </a:txBody>
+                  <a:tcPr marL="73152" marR="73152" marT="18288" marB="18288" anchor="ctr">
+                    <a:lnL w="0" cap="flat" cmpd="sng" algn="ctr">
+                      <a:noFill/>
+                    </a:lnL>
+                    <a:lnR w="0" cap="flat" cmpd="sng" algn="ctr">
+                      <a:noFill/>
+                    </a:lnR>
+                    <a:lnT w="0" cap="flat" cmpd="sng" algn="ctr">
+                      <a:noFill/>
+                    </a:lnT>
+                    <a:lnB w="9525" cap="flat" cmpd="sng" algn="ctr">
+                      <a:solidFill>
+                        <a:srgbClr val="D5DBD6"/>
+                      </a:solidFill>
+                      <a:prstDash val="solid"/>
+                      <a:round/>
+                      <a:headEnd type="none" w="med" len="med"/>
+                      <a:tailEnd type="none" w="med" len="med"/>
+                    </a:lnB>
+                  </a:tcPr>
+                </a:tc>
+                <a:tc>
+                  <a:txBody>
+                    <a:bodyPr/>
+                    <a:lstStyle/>
+                    <a:p>
+                      <a:pPr algn="r" indent="0" marL="0">
+                        <a:buNone/>
+                      </a:pPr>
+                      <a:r>
+                        <a:rPr lang="en-US" sz="1200" dirty="0">
+                          <a:solidFill>
+                            <a:srgbClr val="1B2420"/>
+                          </a:solidFill>
+                          <a:latin typeface="Calibri" pitchFamily="34" charset="0"/>
+                          <a:ea typeface="Calibri" pitchFamily="34" charset="-122"/>
+                          <a:cs typeface="Calibri" pitchFamily="34" charset="-120"/>
+                        </a:rPr>
+                        <a:t>338.752</a:t>
+                      </a:r>
+                      <a:endParaRPr lang="en-US" sz="1200" dirty="0">
+                        <a:latin typeface="Calibri" charset="0"/>
+                        <a:ea typeface="Calibri" charset="0"/>
+                        <a:cs typeface="Calibri" charset="0"/>
+                      </a:endParaRPr>
+                    </a:p>
+                  </a:txBody>
+                  <a:tcPr marL="73152" marR="73152" marT="18288" marB="18288" anchor="ctr">
+                    <a:lnL w="0" cap="flat" cmpd="sng" algn="ctr">
+                      <a:noFill/>
+                    </a:lnL>
+                    <a:lnR w="0" cap="flat" cmpd="sng" algn="ctr">
+                      <a:noFill/>
+                    </a:lnR>
+                    <a:lnT w="0" cap="flat" cmpd="sng" algn="ctr">
+                      <a:noFill/>
+                    </a:lnT>
+                    <a:lnB w="9525" cap="flat" cmpd="sng" algn="ctr">
+                      <a:solidFill>
+                        <a:srgbClr val="D5DBD6"/>
+                      </a:solidFill>
+                      <a:prstDash val="solid"/>
+                      <a:round/>
+                      <a:headEnd type="none" w="med" len="med"/>
+                      <a:tailEnd type="none" w="med" len="med"/>
+                    </a:lnB>
+                  </a:tcPr>
+                </a:tc>
+              </a:tr>
+              <a:tr h="292608">
+                <a:tc>
+                  <a:txBody>
+                    <a:bodyPr/>
+                    <a:lstStyle/>
+                    <a:p>
+                      <a:pPr algn="l" indent="0" marL="0">
+                        <a:buNone/>
+                      </a:pPr>
+                      <a:r>
+                        <a:rPr lang="en-US" sz="1200" dirty="0">
+                          <a:solidFill>
+                            <a:srgbClr val="1B2420"/>
+                          </a:solidFill>
+                          <a:latin typeface="Calibri" pitchFamily="34" charset="0"/>
+                          <a:ea typeface="Calibri" pitchFamily="34" charset="-122"/>
+                          <a:cs typeface="Calibri" pitchFamily="34" charset="-120"/>
+                        </a:rPr>
+                        <a:t>Tuplah</a:t>
+                      </a:r>
+                      <a:endParaRPr lang="en-US" sz="1200" dirty="0">
+                        <a:latin typeface="Calibri" charset="0"/>
+                        <a:ea typeface="Calibri" charset="0"/>
+                        <a:cs typeface="Calibri" charset="0"/>
+                      </a:endParaRPr>
+                    </a:p>
+                  </a:txBody>
+                  <a:tcPr marL="73152" marR="73152" marT="18288" marB="18288" anchor="ctr">
+                    <a:lnL w="0" cap="flat" cmpd="sng" algn="ctr">
+                      <a:noFill/>
+                    </a:lnL>
+                    <a:lnR w="0" cap="flat" cmpd="sng" algn="ctr">
+                      <a:noFill/>
+                    </a:lnR>
+                    <a:lnT w="0" cap="flat" cmpd="sng" algn="ctr">
+                      <a:noFill/>
+                    </a:lnT>
+                    <a:lnB w="9525" cap="flat" cmpd="sng" algn="ctr">
+                      <a:solidFill>
+                        <a:srgbClr val="D5DBD6"/>
+                      </a:solidFill>
+                      <a:prstDash val="solid"/>
+                      <a:round/>
+                      <a:headEnd type="none" w="med" len="med"/>
+                      <a:tailEnd type="none" w="med" len="med"/>
+                    </a:lnB>
+                  </a:tcPr>
+                </a:tc>
+                <a:tc>
+                  <a:txBody>
+                    <a:bodyPr/>
+                    <a:lstStyle/>
+                    <a:p>
+                      <a:pPr algn="r" indent="0" marL="0">
+                        <a:buNone/>
+                      </a:pPr>
+                      <a:r>
+                        <a:rPr lang="en-US" sz="1200" dirty="0">
+                          <a:solidFill>
+                            <a:srgbClr val="1B2420"/>
+                          </a:solidFill>
+                          <a:latin typeface="Calibri" pitchFamily="34" charset="0"/>
+                          <a:ea typeface="Calibri" pitchFamily="34" charset="-122"/>
+                          <a:cs typeface="Calibri" pitchFamily="34" charset="-120"/>
+                        </a:rPr>
+                        <a:t>1.315.759</a:t>
+                      </a:r>
+                      <a:endParaRPr lang="en-US" sz="1200" dirty="0">
+                        <a:latin typeface="Calibri" charset="0"/>
+                        <a:ea typeface="Calibri" charset="0"/>
+                        <a:cs typeface="Calibri" charset="0"/>
+                      </a:endParaRPr>
+                    </a:p>
+                  </a:txBody>
+                  <a:tcPr marL="73152" marR="73152" marT="18288" marB="18288" anchor="ctr">
+                    <a:lnL w="0" cap="flat" cmpd="sng" algn="ctr">
+                      <a:noFill/>
+                    </a:lnL>
+                    <a:lnR w="0" cap="flat" cmpd="sng" algn="ctr">
+                      <a:noFill/>
+                    </a:lnR>
+                    <a:lnT w="0" cap="flat" cmpd="sng" algn="ctr">
+                      <a:noFill/>
+                    </a:lnT>
+                    <a:lnB w="9525" cap="flat" cmpd="sng" algn="ctr">
+                      <a:solidFill>
+                        <a:srgbClr val="D5DBD6"/>
+                      </a:solidFill>
+                      <a:prstDash val="solid"/>
+                      <a:round/>
+                      <a:headEnd type="none" w="med" len="med"/>
+                      <a:tailEnd type="none" w="med" len="med"/>
+                    </a:lnB>
+                  </a:tcPr>
+                </a:tc>
+                <a:tc>
+                  <a:txBody>
+                    <a:bodyPr/>
+                    <a:lstStyle/>
+                    <a:p>
+                      <a:pPr algn="r" indent="0" marL="0">
+                        <a:buNone/>
+                      </a:pPr>
+                      <a:r>
+                        <a:rPr lang="en-US" sz="1200" dirty="0">
+                          <a:solidFill>
+                            <a:srgbClr val="1B2420"/>
+                          </a:solidFill>
+                          <a:latin typeface="Calibri" pitchFamily="34" charset="0"/>
+                          <a:ea typeface="Calibri" pitchFamily="34" charset="-122"/>
+                          <a:cs typeface="Calibri" pitchFamily="34" charset="-120"/>
+                        </a:rPr>
+                        <a:t>4.824.448</a:t>
+                      </a:r>
+                      <a:endParaRPr lang="en-US" sz="1200" dirty="0">
+                        <a:latin typeface="Calibri" charset="0"/>
+                        <a:ea typeface="Calibri" charset="0"/>
+                        <a:cs typeface="Calibri" charset="0"/>
+                      </a:endParaRPr>
+                    </a:p>
+                  </a:txBody>
+                  <a:tcPr marL="73152" marR="73152" marT="18288" marB="18288" anchor="ctr">
+                    <a:lnL w="0" cap="flat" cmpd="sng" algn="ctr">
+                      <a:noFill/>
+                    </a:lnL>
+                    <a:lnR w="0" cap="flat" cmpd="sng" algn="ctr">
+                      <a:noFill/>
+                    </a:lnR>
+                    <a:lnT w="0" cap="flat" cmpd="sng" algn="ctr">
+                      <a:noFill/>
+                    </a:lnT>
+                    <a:lnB w="9525" cap="flat" cmpd="sng" algn="ctr">
+                      <a:solidFill>
+                        <a:srgbClr val="D5DBD6"/>
+                      </a:solidFill>
+                      <a:prstDash val="solid"/>
+                      <a:round/>
+                      <a:headEnd type="none" w="med" len="med"/>
+                      <a:tailEnd type="none" w="med" len="med"/>
+                    </a:lnB>
+                  </a:tcPr>
+                </a:tc>
+              </a:tr>
+              <a:tr h="292608">
+                <a:tc>
+                  <a:txBody>
+                    <a:bodyPr/>
+                    <a:lstStyle/>
+                    <a:p>
+                      <a:pPr algn="l" indent="0" marL="0">
+                        <a:buNone/>
+                      </a:pPr>
+                      <a:r>
+                        <a:rPr lang="en-US" sz="1200" b="1" dirty="0">
+                          <a:solidFill>
+                            <a:srgbClr val="1B2420"/>
+                          </a:solidFill>
+                          <a:latin typeface="Calibri" pitchFamily="34" charset="0"/>
+                          <a:ea typeface="Calibri" pitchFamily="34" charset="-122"/>
+                          <a:cs typeface="Calibri" pitchFamily="34" charset="-120"/>
+                        </a:rPr>
+                        <a:t>Total stok karbon</a:t>
+                      </a:r>
+                      <a:endParaRPr lang="en-US" sz="1200" dirty="0">
+                        <a:latin typeface="Calibri" charset="0"/>
+                        <a:ea typeface="Calibri" charset="0"/>
+                        <a:cs typeface="Calibri" charset="0"/>
+                      </a:endParaRPr>
+                    </a:p>
+                  </a:txBody>
+                  <a:tcPr marL="73152" marR="73152" marT="18288" marB="18288" anchor="ctr">
+                    <a:lnL w="0" cap="flat" cmpd="sng" algn="ctr">
+                      <a:noFill/>
+                    </a:lnL>
+                    <a:lnR w="0" cap="flat" cmpd="sng" algn="ctr">
+                      <a:noFill/>
+                    </a:lnR>
+                    <a:lnT w="0" cap="flat" cmpd="sng" algn="ctr">
+                      <a:noFill/>
+                    </a:lnT>
+                    <a:lnB w="9525" cap="flat" cmpd="sng" algn="ctr">
+                      <a:solidFill>
+                        <a:srgbClr val="D5DBD6"/>
+                      </a:solidFill>
+                      <a:prstDash val="solid"/>
+                      <a:round/>
+                      <a:headEnd type="none" w="med" len="med"/>
+                      <a:tailEnd type="none" w="med" len="med"/>
+                    </a:lnB>
+                  </a:tcPr>
+                </a:tc>
+                <a:tc>
+                  <a:txBody>
+                    <a:bodyPr/>
+                    <a:lstStyle/>
+                    <a:p>
+                      <a:pPr algn="r" indent="0" marL="0">
+                        <a:buNone/>
+                      </a:pPr>
+                      <a:r>
+                        <a:rPr lang="en-US" sz="1200" b="1" dirty="0">
+                          <a:solidFill>
+                            <a:srgbClr val="1B2420"/>
+                          </a:solidFill>
+                          <a:latin typeface="Calibri" pitchFamily="34" charset="0"/>
+                          <a:ea typeface="Calibri" pitchFamily="34" charset="-122"/>
+                          <a:cs typeface="Calibri" pitchFamily="34" charset="-120"/>
+                        </a:rPr>
+                        <a:t>1.418.967</a:t>
+                      </a:r>
+                      <a:endParaRPr lang="en-US" sz="1200" dirty="0">
+                        <a:latin typeface="Calibri" charset="0"/>
+                        <a:ea typeface="Calibri" charset="0"/>
+                        <a:cs typeface="Calibri" charset="0"/>
+                      </a:endParaRPr>
+                    </a:p>
+                  </a:txBody>
+                  <a:tcPr marL="73152" marR="73152" marT="18288" marB="18288" anchor="ctr">
+                    <a:lnL w="0" cap="flat" cmpd="sng" algn="ctr">
+                      <a:noFill/>
+                    </a:lnL>
+                    <a:lnR w="0" cap="flat" cmpd="sng" algn="ctr">
+                      <a:noFill/>
+                    </a:lnR>
+                    <a:lnT w="0" cap="flat" cmpd="sng" algn="ctr">
+                      <a:noFill/>
+                    </a:lnT>
+                    <a:lnB w="9525" cap="flat" cmpd="sng" algn="ctr">
+                      <a:solidFill>
+                        <a:srgbClr val="D5DBD6"/>
+                      </a:solidFill>
+                      <a:prstDash val="solid"/>
+                      <a:round/>
+                      <a:headEnd type="none" w="med" len="med"/>
+                      <a:tailEnd type="none" w="med" len="med"/>
+                    </a:lnB>
+                  </a:tcPr>
+                </a:tc>
+                <a:tc>
+                  <a:txBody>
+                    <a:bodyPr/>
+                    <a:lstStyle/>
+                    <a:p>
+                      <a:pPr algn="r" indent="0" marL="0">
+                        <a:buNone/>
+                      </a:pPr>
+                      <a:r>
+                        <a:rPr lang="en-US" sz="1200" b="1" dirty="0">
+                          <a:solidFill>
+                            <a:srgbClr val="1B2420"/>
+                          </a:solidFill>
+                          <a:latin typeface="Calibri" pitchFamily="34" charset="0"/>
+                          <a:ea typeface="Calibri" pitchFamily="34" charset="-122"/>
+                          <a:cs typeface="Calibri" pitchFamily="34" charset="-120"/>
+                        </a:rPr>
+                        <a:t>5.202.879</a:t>
+                      </a:r>
+                      <a:endParaRPr lang="en-US" sz="1200" dirty="0">
+                        <a:latin typeface="Calibri" charset="0"/>
+                        <a:ea typeface="Calibri" charset="0"/>
+                        <a:cs typeface="Calibri" charset="0"/>
+                      </a:endParaRPr>
+                    </a:p>
+                  </a:txBody>
+                  <a:tcPr marL="73152" marR="73152" marT="18288" marB="18288" anchor="ctr">
+                    <a:lnL w="0" cap="flat" cmpd="sng" algn="ctr">
+                      <a:noFill/>
+                    </a:lnL>
+                    <a:lnR w="0" cap="flat" cmpd="sng" algn="ctr">
+                      <a:noFill/>
+                    </a:lnR>
+                    <a:lnT w="0" cap="flat" cmpd="sng" algn="ctr">
+                      <a:noFill/>
+                    </a:lnT>
+                    <a:lnB w="9525" cap="flat" cmpd="sng" algn="ctr">
+                      <a:solidFill>
+                        <a:srgbClr val="D5DBD6"/>
+                      </a:solidFill>
+                      <a:prstDash val="solid"/>
+                      <a:round/>
+                      <a:headEnd type="none" w="med" len="med"/>
+                      <a:tailEnd type="none" w="med" len="med"/>
+                    </a:lnB>
+                  </a:tcPr>
+                </a:tc>
+              </a:tr>
+              <a:tr h="292608">
+                <a:tc>
+                  <a:txBody>
+                    <a:bodyPr/>
+                    <a:lstStyle/>
+                    <a:p>
+                      <a:pPr algn="l" indent="0" marL="0">
+                        <a:buNone/>
+                      </a:pPr>
+                      <a:r>
+                        <a:rPr lang="en-US" sz="1200" dirty="0">
+                          <a:solidFill>
+                            <a:srgbClr val="1B2420"/>
+                          </a:solidFill>
+                          <a:latin typeface="Calibri" pitchFamily="34" charset="0"/>
+                          <a:ea typeface="Calibri" pitchFamily="34" charset="-122"/>
+                          <a:cs typeface="Calibri" pitchFamily="34" charset="-120"/>
+                        </a:rPr>
+                        <a:t>Buffer</a:t>
+                      </a:r>
+                      <a:endParaRPr lang="en-US" sz="1200" dirty="0">
+                        <a:latin typeface="Calibri" charset="0"/>
+                        <a:ea typeface="Calibri" charset="0"/>
+                        <a:cs typeface="Calibri" charset="0"/>
+                      </a:endParaRPr>
+                    </a:p>
+                  </a:txBody>
+                  <a:tcPr marL="73152" marR="73152" marT="18288" marB="18288" anchor="ctr">
+                    <a:lnL w="0" cap="flat" cmpd="sng" algn="ctr">
+                      <a:noFill/>
+                    </a:lnL>
+                    <a:lnR w="0" cap="flat" cmpd="sng" algn="ctr">
+                      <a:noFill/>
+                    </a:lnR>
+                    <a:lnT w="0" cap="flat" cmpd="sng" algn="ctr">
+                      <a:noFill/>
+                    </a:lnT>
+                    <a:lnB w="9525" cap="flat" cmpd="sng" algn="ctr">
+                      <a:solidFill>
+                        <a:srgbClr val="D5DBD6"/>
+                      </a:solidFill>
+                      <a:prstDash val="solid"/>
+                      <a:round/>
+                      <a:headEnd type="none" w="med" len="med"/>
+                      <a:tailEnd type="none" w="med" len="med"/>
+                    </a:lnB>
+                  </a:tcPr>
+                </a:tc>
+                <a:tc>
+                  <a:txBody>
+                    <a:bodyPr/>
+                    <a:lstStyle/>
+                    <a:p>
+                      <a:pPr algn="r" indent="0" marL="0">
+                        <a:buNone/>
+                      </a:pPr>
+                      <a:endParaRPr lang="en-US" sz="1200" dirty="0">
+                        <a:latin typeface="Calibri" charset="0"/>
+                        <a:ea typeface="Calibri" charset="0"/>
+                        <a:cs typeface="Calibri" charset="0"/>
+                      </a:endParaRPr>
+                    </a:p>
+                  </a:txBody>
+                  <a:tcPr marL="73152" marR="73152" marT="18288" marB="18288" anchor="ctr">
+                    <a:lnL w="0" cap="flat" cmpd="sng" algn="ctr">
+                      <a:noFill/>
+                    </a:lnL>
+                    <a:lnR w="0" cap="flat" cmpd="sng" algn="ctr">
+                      <a:noFill/>
+                    </a:lnR>
+                    <a:lnT w="0" cap="flat" cmpd="sng" algn="ctr">
+                      <a:noFill/>
+                    </a:lnT>
+                    <a:lnB w="9525" cap="flat" cmpd="sng" algn="ctr">
+                      <a:solidFill>
+                        <a:srgbClr val="D5DBD6"/>
+                      </a:solidFill>
+                      <a:prstDash val="solid"/>
+                      <a:round/>
+                      <a:headEnd type="none" w="med" len="med"/>
+                      <a:tailEnd type="none" w="med" len="med"/>
+                    </a:lnB>
+                  </a:tcPr>
+                </a:tc>
+                <a:tc>
+                  <a:txBody>
+                    <a:bodyPr/>
+                    <a:lstStyle/>
+                    <a:p>
+                      <a:pPr algn="r" indent="0" marL="0">
+                        <a:buNone/>
+                      </a:pPr>
+                      <a:r>
+                        <a:rPr lang="en-US" sz="1200" dirty="0">
+                          <a:solidFill>
+                            <a:srgbClr val="1B2420"/>
+                          </a:solidFill>
+                          <a:latin typeface="Calibri" pitchFamily="34" charset="0"/>
+                          <a:ea typeface="Calibri" pitchFamily="34" charset="-122"/>
+                          <a:cs typeface="Calibri" pitchFamily="34" charset="-120"/>
+                        </a:rPr>
+                        <a:t>2.601.440</a:t>
+                      </a:r>
+                      <a:endParaRPr lang="en-US" sz="1200" dirty="0">
+                        <a:latin typeface="Calibri" charset="0"/>
+                        <a:ea typeface="Calibri" charset="0"/>
+                        <a:cs typeface="Calibri" charset="0"/>
+                      </a:endParaRPr>
+                    </a:p>
+                  </a:txBody>
+                  <a:tcPr marL="73152" marR="73152" marT="18288" marB="18288" anchor="ctr">
+                    <a:lnL w="0" cap="flat" cmpd="sng" algn="ctr">
+                      <a:noFill/>
+                    </a:lnL>
+                    <a:lnR w="0" cap="flat" cmpd="sng" algn="ctr">
+                      <a:noFill/>
+                    </a:lnR>
+                    <a:lnT w="0" cap="flat" cmpd="sng" algn="ctr">
+                      <a:noFill/>
+                    </a:lnT>
+                    <a:lnB w="9525" cap="flat" cmpd="sng" algn="ctr">
+                      <a:solidFill>
+                        <a:srgbClr val="D5DBD6"/>
+                      </a:solidFill>
+                      <a:prstDash val="solid"/>
+                      <a:round/>
+                      <a:headEnd type="none" w="med" len="med"/>
+                      <a:tailEnd type="none" w="med" len="med"/>
+                    </a:lnB>
+                  </a:tcPr>
+                </a:tc>
+              </a:tr>
+              <a:tr h="292608">
+                <a:tc>
+                  <a:txBody>
+                    <a:bodyPr/>
+                    <a:lstStyle/>
+                    <a:p>
+                      <a:pPr algn="l" indent="0" marL="0">
+                        <a:buNone/>
+                      </a:pPr>
+                      <a:r>
+                        <a:rPr lang="en-US" sz="1200" b="1" dirty="0">
+                          <a:solidFill>
+                            <a:srgbClr val="1F5A45"/>
+                          </a:solidFill>
+                          <a:latin typeface="Calibri" pitchFamily="34" charset="0"/>
+                          <a:ea typeface="Calibri" pitchFamily="34" charset="-122"/>
+                          <a:cs typeface="Calibri" pitchFamily="34" charset="-120"/>
+                        </a:rPr>
+                        <a:t>Net VCU (100%)</a:t>
+                      </a:r>
+                      <a:endParaRPr lang="en-US" sz="1200" dirty="0">
+                        <a:latin typeface="Calibri" charset="0"/>
+                        <a:ea typeface="Calibri" charset="0"/>
+                        <a:cs typeface="Calibri" charset="0"/>
+                      </a:endParaRPr>
+                    </a:p>
+                  </a:txBody>
+                  <a:tcPr marL="73152" marR="73152" marT="18288" marB="18288" anchor="ctr">
+                    <a:lnL w="0" cap="flat" cmpd="sng" algn="ctr">
+                      <a:noFill/>
+                    </a:lnL>
+                    <a:lnR w="0" cap="flat" cmpd="sng" algn="ctr">
+                      <a:noFill/>
+                    </a:lnR>
+                    <a:lnT w="0" cap="flat" cmpd="sng" algn="ctr">
+                      <a:noFill/>
+                    </a:lnT>
+                    <a:lnB w="9525" cap="flat" cmpd="sng" algn="ctr">
+                      <a:solidFill>
+                        <a:srgbClr val="D5DBD6"/>
+                      </a:solidFill>
+                      <a:prstDash val="solid"/>
+                      <a:round/>
+                      <a:headEnd type="none" w="med" len="med"/>
+                      <a:tailEnd type="none" w="med" len="med"/>
+                    </a:lnB>
+                  </a:tcPr>
+                </a:tc>
+                <a:tc>
+                  <a:txBody>
+                    <a:bodyPr/>
+                    <a:lstStyle/>
+                    <a:p>
+                      <a:pPr algn="r" indent="0" marL="0">
+                        <a:buNone/>
+                      </a:pPr>
+                      <a:endParaRPr lang="en-US" sz="1200" dirty="0">
+                        <a:latin typeface="Calibri" charset="0"/>
+                        <a:ea typeface="Calibri" charset="0"/>
+                        <a:cs typeface="Calibri" charset="0"/>
+                      </a:endParaRPr>
+                    </a:p>
+                  </a:txBody>
+                  <a:tcPr marL="73152" marR="73152" marT="18288" marB="18288" anchor="ctr">
+                    <a:lnL w="0" cap="flat" cmpd="sng" algn="ctr">
+                      <a:noFill/>
+                    </a:lnL>
+                    <a:lnR w="0" cap="flat" cmpd="sng" algn="ctr">
+                      <a:noFill/>
+                    </a:lnR>
+                    <a:lnT w="0" cap="flat" cmpd="sng" algn="ctr">
+                      <a:noFill/>
+                    </a:lnT>
+                    <a:lnB w="9525" cap="flat" cmpd="sng" algn="ctr">
+                      <a:solidFill>
+                        <a:srgbClr val="D5DBD6"/>
+                      </a:solidFill>
+                      <a:prstDash val="solid"/>
+                      <a:round/>
+                      <a:headEnd type="none" w="med" len="med"/>
+                      <a:tailEnd type="none" w="med" len="med"/>
+                    </a:lnB>
+                  </a:tcPr>
+                </a:tc>
+                <a:tc>
+                  <a:txBody>
+                    <a:bodyPr/>
+                    <a:lstStyle/>
+                    <a:p>
+                      <a:pPr algn="r" indent="0" marL="0">
+                        <a:buNone/>
+                      </a:pPr>
+                      <a:r>
+                        <a:rPr lang="en-US" sz="1200" b="1" dirty="0">
+                          <a:solidFill>
+                            <a:srgbClr val="1F5A45"/>
+                          </a:solidFill>
+                          <a:latin typeface="Calibri" pitchFamily="34" charset="0"/>
+                          <a:ea typeface="Calibri" pitchFamily="34" charset="-122"/>
+                          <a:cs typeface="Calibri" pitchFamily="34" charset="-120"/>
+                        </a:rPr>
+                        <a:t>9.807,43</a:t>
+                      </a:r>
+                      <a:endParaRPr lang="en-US" sz="1200" dirty="0">
+                        <a:latin typeface="Calibri" charset="0"/>
+                        <a:ea typeface="Calibri" charset="0"/>
+                        <a:cs typeface="Calibri" charset="0"/>
+                      </a:endParaRPr>
+                    </a:p>
+                  </a:txBody>
+                  <a:tcPr marL="73152" marR="73152" marT="18288" marB="18288" anchor="ctr">
+                    <a:lnL w="0" cap="flat" cmpd="sng" algn="ctr">
+                      <a:noFill/>
+                    </a:lnL>
+                    <a:lnR w="0" cap="flat" cmpd="sng" algn="ctr">
+                      <a:noFill/>
+                    </a:lnR>
+                    <a:lnT w="0" cap="flat" cmpd="sng" algn="ctr">
+                      <a:noFill/>
+                    </a:lnT>
+                    <a:lnB w="9525" cap="flat" cmpd="sng" algn="ctr">
+                      <a:solidFill>
+                        <a:srgbClr val="D5DBD6"/>
+                      </a:solidFill>
+                      <a:prstDash val="solid"/>
+                      <a:round/>
+                      <a:headEnd type="none" w="med" len="med"/>
+                      <a:tailEnd type="none" w="med" len="med"/>
+                    </a:lnB>
+                  </a:tcPr>
+                </a:tc>
+              </a:tr>
+              <a:tr h="292608">
+                <a:tc>
+                  <a:txBody>
+                    <a:bodyPr/>
+                    <a:lstStyle/>
+                    <a:p>
+                      <a:pPr algn="l" indent="0" marL="0">
+                        <a:buNone/>
+                      </a:pPr>
+                      <a:r>
+                        <a:rPr lang="en-US" sz="1200" b="1" dirty="0">
+                          <a:solidFill>
+                            <a:srgbClr val="1F5A45"/>
+                          </a:solidFill>
+                          <a:latin typeface="Calibri" pitchFamily="34" charset="0"/>
+                          <a:ea typeface="Calibri" pitchFamily="34" charset="-122"/>
+                          <a:cs typeface="Calibri" pitchFamily="34" charset="-120"/>
+                        </a:rPr>
+                        <a:t>Porsi LPHD (60%)</a:t>
+                      </a:r>
+                      <a:endParaRPr lang="en-US" sz="1200" dirty="0">
+                        <a:latin typeface="Calibri" charset="0"/>
+                        <a:ea typeface="Calibri" charset="0"/>
+                        <a:cs typeface="Calibri" charset="0"/>
+                      </a:endParaRPr>
+                    </a:p>
+                  </a:txBody>
+                  <a:tcPr marL="73152" marR="73152" marT="18288" marB="18288" anchor="ctr">
+                    <a:lnL w="0" cap="flat" cmpd="sng" algn="ctr">
+                      <a:noFill/>
+                    </a:lnL>
+                    <a:lnR w="0" cap="flat" cmpd="sng" algn="ctr">
+                      <a:noFill/>
+                    </a:lnR>
+                    <a:lnT w="0" cap="flat" cmpd="sng" algn="ctr">
+                      <a:noFill/>
+                    </a:lnT>
+                    <a:lnB w="9525" cap="flat" cmpd="sng" algn="ctr">
+                      <a:solidFill>
+                        <a:srgbClr val="D5DBD6"/>
+                      </a:solidFill>
+                      <a:prstDash val="solid"/>
+                      <a:round/>
+                      <a:headEnd type="none" w="med" len="med"/>
+                      <a:tailEnd type="none" w="med" len="med"/>
+                    </a:lnB>
+                  </a:tcPr>
+                </a:tc>
+                <a:tc>
+                  <a:txBody>
+                    <a:bodyPr/>
+                    <a:lstStyle/>
+                    <a:p>
+                      <a:pPr algn="r" indent="0" marL="0">
+                        <a:buNone/>
+                      </a:pPr>
+                      <a:endParaRPr lang="en-US" sz="1200" dirty="0">
+                        <a:latin typeface="Calibri" charset="0"/>
+                        <a:ea typeface="Calibri" charset="0"/>
+                        <a:cs typeface="Calibri" charset="0"/>
+                      </a:endParaRPr>
+                    </a:p>
+                  </a:txBody>
+                  <a:tcPr marL="73152" marR="73152" marT="18288" marB="18288" anchor="ctr">
+                    <a:lnL w="0" cap="flat" cmpd="sng" algn="ctr">
+                      <a:noFill/>
+                    </a:lnL>
+                    <a:lnR w="0" cap="flat" cmpd="sng" algn="ctr">
+                      <a:noFill/>
+                    </a:lnR>
+                    <a:lnT w="0" cap="flat" cmpd="sng" algn="ctr">
+                      <a:noFill/>
+                    </a:lnT>
+                    <a:lnB w="9525" cap="flat" cmpd="sng" algn="ctr">
+                      <a:solidFill>
+                        <a:srgbClr val="D5DBD6"/>
+                      </a:solidFill>
+                      <a:prstDash val="solid"/>
+                      <a:round/>
+                      <a:headEnd type="none" w="med" len="med"/>
+                      <a:tailEnd type="none" w="med" len="med"/>
+                    </a:lnB>
+                  </a:tcPr>
+                </a:tc>
+                <a:tc>
+                  <a:txBody>
+                    <a:bodyPr/>
+                    <a:lstStyle/>
+                    <a:p>
+                      <a:pPr algn="r" indent="0" marL="0">
+                        <a:buNone/>
+                      </a:pPr>
+                      <a:r>
+                        <a:rPr lang="en-US" sz="1200" b="1" dirty="0">
+                          <a:solidFill>
+                            <a:srgbClr val="1F5A45"/>
+                          </a:solidFill>
+                          <a:latin typeface="Calibri" pitchFamily="34" charset="0"/>
+                          <a:ea typeface="Calibri" pitchFamily="34" charset="-122"/>
+                          <a:cs typeface="Calibri" pitchFamily="34" charset="-120"/>
+                        </a:rPr>
+                        <a:t>5.884</a:t>
+                      </a:r>
+                      <a:endParaRPr lang="en-US" sz="1200" dirty="0">
+                        <a:latin typeface="Calibri" charset="0"/>
+                        <a:ea typeface="Calibri" charset="0"/>
+                        <a:cs typeface="Calibri" charset="0"/>
+                      </a:endParaRPr>
+                    </a:p>
+                  </a:txBody>
+                  <a:tcPr marL="73152" marR="73152" marT="18288" marB="18288" anchor="ctr">
+                    <a:lnL w="0" cap="flat" cmpd="sng" algn="ctr">
+                      <a:noFill/>
+                    </a:lnL>
+                    <a:lnR w="0" cap="flat" cmpd="sng" algn="ctr">
+                      <a:noFill/>
+                    </a:lnR>
+                    <a:lnT w="0" cap="flat" cmpd="sng" algn="ctr">
+                      <a:noFill/>
+                    </a:lnT>
+                    <a:lnB w="9525" cap="flat" cmpd="sng" algn="ctr">
+                      <a:solidFill>
+                        <a:srgbClr val="D5DBD6"/>
+                      </a:solidFill>
+                      <a:prstDash val="solid"/>
+                      <a:round/>
+                      <a:headEnd type="none" w="med" len="med"/>
+                      <a:tailEnd type="none" w="med" len="med"/>
+                    </a:lnB>
+                  </a:tcPr>
+                </a:tc>
+              </a:tr>
+            </a:tbl>
+          </a:graphicData>
+        </a:graphic>
+      </p:graphicFrame>
       <p:sp>
         <p:nvSpPr>
-          <p:cNvPr id="6" name="Text 3"/>
+          <p:cNvPr id="7" name="Text 3"/>
           <p:cNvSpPr txBox="1"/>
           <p:nvPr/>
         </p:nvSpPr>
         <p:spPr>
           <a:xfrm>
-            <a:off x="548640" y="3200400"/>
-            <a:ext cx="3931920" cy="502920"/>
+            <a:off x="548640" y="5623560"/>
+            <a:ext cx="5029200" cy="237744"/>
           </a:xfrm>
           <a:prstGeom prst="rect">
             <a:avLst/>
@@ -1518,34 +2929,23 @@
               <a:buNone/>
             </a:pPr>
             <a:r>
-              <a:rPr lang="en-US" sz="1400" dirty="0">
+              <a:rPr lang="en-US" sz="1200" dirty="0">
                 <a:solidFill>
                   <a:schemeClr val="accent4"/>
                 </a:solidFill>
               </a:rPr>
-              <a:t>dari </a:t>
+              <a:t>Luas areal  </a:t>
             </a:r>
             <a:pPr indent="0" marL="0">
               <a:buNone/>
             </a:pPr>
             <a:r>
-              <a:rPr lang="en-US" sz="1400" b="1" dirty="0">
+              <a:rPr lang="en-US" sz="1200" b="1" dirty="0">
                 <a:solidFill>
                   <a:schemeClr val="tx1"/>
                 </a:solidFill>
               </a:rPr>
-              <a:t>9.807,43</a:t>
-            </a:r>
-            <a:pPr indent="0" marL="0">
-              <a:buNone/>
-            </a:pPr>
-            <a:r>
-              <a:rPr lang="en-US" sz="1400" dirty="0">
-                <a:solidFill>
-                  <a:schemeClr val="accent4"/>
-                </a:solidFill>
-              </a:rPr>
-              <a:t> net VCU seluruh areal, setelah buffer 2.601.440 tCO₂e</a:t>
+              <a:t>2.468,5 ha</a:t>
             </a:r>
             <a:endParaRPr lang="en-US" sz="1400" dirty="0"/>
           </a:p>
@@ -1553,144 +2953,54 @@
       </p:sp>
       <p:sp>
         <p:nvSpPr>
-          <p:cNvPr id="7" name="Shape 4"/>
+          <p:cNvPr id="8" name="luas-arr"/>
           <p:cNvSpPr/>
           <p:nvPr/>
         </p:nvSpPr>
         <p:spPr>
           <a:xfrm>
-            <a:off x="548640" y="3886200"/>
-            <a:ext cx="3931920" cy="0"/>
-          </a:xfrm>
-          <a:prstGeom prst="line">
-            <a:avLst/>
-          </a:prstGeom>
-          <a:noFill/>
-          <a:ln w="9525">
-            <a:solidFill>
-              <a:schemeClr val="accent5"/>
-            </a:solidFill>
-            <a:prstDash val="solid"/>
-          </a:ln>
-        </p:spPr>
-      </p:sp>
-      <p:sp>
-        <p:nvSpPr>
-          <p:cNvPr id="8" name="Text 5"/>
-          <p:cNvSpPr txBox="1"/>
-          <p:nvPr/>
-        </p:nvSpPr>
-        <p:spPr>
-          <a:xfrm>
-            <a:off x="548640" y="4023360"/>
-            <a:ext cx="3931920" cy="274320"/>
-          </a:xfrm>
-          <a:prstGeom prst="rect">
-            <a:avLst/>
-          </a:prstGeom>
-          <a:noFill/>
-          <a:ln/>
-        </p:spPr>
-        <p:txBody>
-          <a:bodyPr wrap="square" lIns="0" tIns="0" rIns="0" bIns="0" rtlCol="0" anchor="t"/>
-          <a:lstStyle/>
-          <a:p>
-            <a:pPr indent="0" marL="0">
-              <a:buNone/>
-            </a:pPr>
-            <a:r>
-              <a:rPr lang="en-US" sz="1300" dirty="0">
-                <a:solidFill>
-                  <a:schemeClr val="accent4"/>
-                </a:solidFill>
-              </a:rPr>
-              <a:t>Stok karbon  </a:t>
-            </a:r>
-            <a:pPr indent="0" marL="0">
-              <a:buNone/>
-            </a:pPr>
-            <a:r>
-              <a:rPr lang="en-US" sz="1300" b="1" dirty="0">
-                <a:solidFill>
-                  <a:schemeClr val="tx1"/>
-                </a:solidFill>
-              </a:rPr>
-              <a:t>5.202.879 tCO₂e</a:t>
-            </a:r>
-            <a:endParaRPr lang="en-US" sz="1400" dirty="0"/>
-          </a:p>
-        </p:txBody>
-      </p:sp>
-      <p:sp>
-        <p:nvSpPr>
-          <p:cNvPr id="9" name="pool-tuplah"/>
-          <p:cNvSpPr/>
-          <p:nvPr/>
-        </p:nvSpPr>
-        <p:spPr>
-          <a:xfrm>
-            <a:off x="548640" y="4370832"/>
-            <a:ext cx="3595059" cy="219456"/>
+            <a:off x="548640" y="5916168"/>
+            <a:ext cx="2924064" cy="164592"/>
           </a:xfrm>
           <a:prstGeom prst="rect">
             <a:avLst/>
           </a:prstGeom>
           <a:solidFill>
-            <a:schemeClr val="accent1"/>
+            <a:schemeClr val="tx2"/>
           </a:solidFill>
           <a:ln/>
         </p:spPr>
       </p:sp>
       <p:sp>
         <p:nvSpPr>
-          <p:cNvPr id="10" name="pool-tanah"/>
+          <p:cNvPr id="9" name="luas-redd"/>
           <p:cNvSpPr/>
           <p:nvPr/>
         </p:nvSpPr>
         <p:spPr>
           <a:xfrm>
-            <a:off x="4171131" y="4370832"/>
-            <a:ext cx="252430" cy="219456"/>
+            <a:off x="3500136" y="5916168"/>
+            <a:ext cx="2077704" cy="164592"/>
           </a:xfrm>
           <a:prstGeom prst="rect">
             <a:avLst/>
           </a:prstGeom>
           <a:solidFill>
-            <a:schemeClr val="accent2"/>
+            <a:schemeClr val="accent6"/>
           </a:solidFill>
           <a:ln/>
         </p:spPr>
       </p:sp>
       <p:sp>
         <p:nvSpPr>
-          <p:cNvPr id="11" name="pool-lain"/>
-          <p:cNvSpPr/>
-          <p:nvPr/>
-        </p:nvSpPr>
-        <p:spPr>
-          <a:xfrm>
-            <a:off x="4450993" y="4370832"/>
-            <a:ext cx="36576" cy="219456"/>
-          </a:xfrm>
-          <a:prstGeom prst="rect">
-            <a:avLst/>
-          </a:prstGeom>
-          <a:solidFill>
-            <a:schemeClr val="accent5"/>
-          </a:solidFill>
-          <a:ln/>
-        </p:spPr>
-      </p:sp>
-      <p:sp>
-        <p:nvSpPr>
-          <p:cNvPr id="12" name="Text 9"/>
+          <p:cNvPr id="10" name="Text 6"/>
           <p:cNvSpPr txBox="1"/>
           <p:nvPr/>
         </p:nvSpPr>
         <p:spPr>
           <a:xfrm>
-            <a:off x="548640" y="4663440"/>
-            <a:ext cx="3931920" cy="256032"/>
+            <a:off x="548640" y="6153912"/>
+            <a:ext cx="2924064" cy="219456"/>
           </a:xfrm>
           <a:prstGeom prst="rect">
             <a:avLst/>
@@ -1711,7 +3021,7 @@
                   <a:schemeClr val="accent4"/>
                 </a:solidFill>
               </a:rPr>
-              <a:t>Tuplah 92,7%  ·  tanah 6,5%  ·  AGB, BGB, serasah 0,8%</a:t>
+              <a:t>Hutan · ARR  1.443,1 ha</a:t>
             </a:r>
             <a:endParaRPr lang="en-US" sz="1100" dirty="0"/>
           </a:p>
@@ -1719,124 +3029,14 @@
       </p:sp>
       <p:sp>
         <p:nvSpPr>
-          <p:cNvPr id="13" name="Shape 10"/>
-          <p:cNvSpPr/>
-          <p:nvPr/>
-        </p:nvSpPr>
-        <p:spPr>
-          <a:xfrm>
-            <a:off x="548640" y="5074920"/>
-            <a:ext cx="3931920" cy="0"/>
-          </a:xfrm>
-          <a:prstGeom prst="line">
-            <a:avLst/>
-          </a:prstGeom>
-          <a:noFill/>
-          <a:ln w="9525">
-            <a:solidFill>
-              <a:schemeClr val="accent5"/>
-            </a:solidFill>
-            <a:prstDash val="solid"/>
-          </a:ln>
-        </p:spPr>
-      </p:sp>
-      <p:sp>
-        <p:nvSpPr>
-          <p:cNvPr id="14" name="Text 11"/>
+          <p:cNvPr id="11" name="Text 7"/>
           <p:cNvSpPr txBox="1"/>
           <p:nvPr/>
         </p:nvSpPr>
         <p:spPr>
           <a:xfrm>
-            <a:off x="548640" y="5212080"/>
-            <a:ext cx="3931920" cy="274320"/>
-          </a:xfrm>
-          <a:prstGeom prst="rect">
-            <a:avLst/>
-          </a:prstGeom>
-          <a:noFill/>
-          <a:ln/>
-        </p:spPr>
-        <p:txBody>
-          <a:bodyPr wrap="square" lIns="0" tIns="0" rIns="0" bIns="0" rtlCol="0" anchor="t"/>
-          <a:lstStyle/>
-          <a:p>
-            <a:pPr indent="0" marL="0">
-              <a:buNone/>
-            </a:pPr>
-            <a:r>
-              <a:rPr lang="en-US" sz="1300" dirty="0">
-                <a:solidFill>
-                  <a:schemeClr val="accent4"/>
-                </a:solidFill>
-              </a:rPr>
-              <a:t>Luas areal  </a:t>
-            </a:r>
-            <a:pPr indent="0" marL="0">
-              <a:buNone/>
-            </a:pPr>
-            <a:r>
-              <a:rPr lang="en-US" sz="1300" b="1" dirty="0">
-                <a:solidFill>
-                  <a:schemeClr val="tx1"/>
-                </a:solidFill>
-              </a:rPr>
-              <a:t>2.468,5 ha</a:t>
-            </a:r>
-            <a:endParaRPr lang="en-US" sz="1400" dirty="0"/>
-          </a:p>
-        </p:txBody>
-      </p:sp>
-      <p:sp>
-        <p:nvSpPr>
-          <p:cNvPr id="15" name="luas-arr"/>
-          <p:cNvSpPr/>
-          <p:nvPr/>
-        </p:nvSpPr>
-        <p:spPr>
-          <a:xfrm>
-            <a:off x="548640" y="5559552"/>
-            <a:ext cx="2282587" cy="219456"/>
-          </a:xfrm>
-          <a:prstGeom prst="rect">
-            <a:avLst/>
-          </a:prstGeom>
-          <a:solidFill>
-            <a:schemeClr val="tx2"/>
-          </a:solidFill>
-          <a:ln/>
-        </p:spPr>
-      </p:sp>
-      <p:sp>
-        <p:nvSpPr>
-          <p:cNvPr id="16" name="luas-redd"/>
-          <p:cNvSpPr/>
-          <p:nvPr/>
-        </p:nvSpPr>
-        <p:spPr>
-          <a:xfrm>
-            <a:off x="2858659" y="5559552"/>
-            <a:ext cx="1621901" cy="219456"/>
-          </a:xfrm>
-          <a:prstGeom prst="rect">
-            <a:avLst/>
-          </a:prstGeom>
-          <a:solidFill>
-            <a:schemeClr val="accent6"/>
-          </a:solidFill>
-          <a:ln/>
-        </p:spPr>
-      </p:sp>
-      <p:sp>
-        <p:nvSpPr>
-          <p:cNvPr id="17" name="Text 14"/>
-          <p:cNvSpPr txBox="1"/>
-          <p:nvPr/>
-        </p:nvSpPr>
-        <p:spPr>
-          <a:xfrm>
-            <a:off x="548640" y="5852160"/>
-            <a:ext cx="2282587" cy="411480"/>
+            <a:off x="3500136" y="6153912"/>
+            <a:ext cx="2077704" cy="219456"/>
           </a:xfrm>
           <a:prstGeom prst="rect">
             <a:avLst/>
@@ -1857,85 +3057,21 @@
                   <a:schemeClr val="accent4"/>
                 </a:solidFill>
               </a:rPr>
-              <a:t>Hutan · ARR</a:t>
+              <a:t>Terdegradasi · REDD  1.025,4 ha</a:t>
             </a:r>
-            <a:endParaRPr lang="en-US" sz="1400" dirty="0"/>
-          </a:p>
-          <a:p>
-            <a:pPr indent="0" marL="0">
-              <a:buNone/>
-            </a:pPr>
-            <a:r>
-              <a:rPr lang="en-US" sz="1200" b="1" dirty="0">
-                <a:solidFill>
-                  <a:schemeClr val="tx1"/>
-                </a:solidFill>
-              </a:rPr>
-              <a:t>1.443,1 ha</a:t>
-            </a:r>
-            <a:endParaRPr lang="en-US" sz="1400" dirty="0"/>
-          </a:p>
-        </p:txBody>
-      </p:sp>
-      <p:sp>
-        <p:nvSpPr>
-          <p:cNvPr id="18" name="Text 15"/>
-          <p:cNvSpPr txBox="1"/>
-          <p:nvPr/>
-        </p:nvSpPr>
-        <p:spPr>
-          <a:xfrm>
-            <a:off x="2858659" y="5852160"/>
-            <a:ext cx="1621901" cy="411480"/>
-          </a:xfrm>
-          <a:prstGeom prst="rect">
-            <a:avLst/>
-          </a:prstGeom>
-          <a:noFill/>
-          <a:ln/>
-        </p:spPr>
-        <p:txBody>
-          <a:bodyPr wrap="square" lIns="0" tIns="0" rIns="0" bIns="0" rtlCol="0" anchor="t"/>
-          <a:lstStyle/>
-          <a:p>
-            <a:pPr indent="0" marL="0">
-              <a:buNone/>
-            </a:pPr>
-            <a:r>
-              <a:rPr lang="en-US" sz="1100" dirty="0">
-                <a:solidFill>
-                  <a:schemeClr val="accent4"/>
-                </a:solidFill>
-              </a:rPr>
-              <a:t>Terdegradasi · REDD</a:t>
-            </a:r>
-            <a:endParaRPr lang="en-US" sz="1400" dirty="0"/>
-          </a:p>
-          <a:p>
-            <a:pPr indent="0" marL="0">
-              <a:buNone/>
-            </a:pPr>
-            <a:r>
-              <a:rPr lang="en-US" sz="1200" b="1" dirty="0">
-                <a:solidFill>
-                  <a:schemeClr val="tx1"/>
-                </a:solidFill>
-              </a:rPr>
-              <a:t>1.025,4 ha</a:t>
-            </a:r>
-            <a:endParaRPr lang="en-US" sz="1400" dirty="0"/>
+            <a:endParaRPr lang="en-US" sz="1100" dirty="0"/>
           </a:p>
         </p:txBody>
       </p:sp>
       <p:graphicFrame>
         <p:nvGraphicFramePr>
-          <p:cNvPr id="19" name="Chart 0" descr=""/>
+          <p:cNvPr id="12" name="Chart 0" descr=""/>
           <p:cNvGraphicFramePr/>
           <p:nvPr/>
         </p:nvGraphicFramePr>
         <p:xfrm>
-          <a:off x="5029200" y="1828800"/>
-          <a:ext cx="6613855" cy="4160520"/>
+          <a:off x="6035040" y="1783080"/>
+          <a:ext cx="5608015" cy="2788920"/>
         </p:xfrm>
         <a:graphic xmlns:a="http://schemas.openxmlformats.org/drawingml/2006/main">
           <a:graphicData uri="http://schemas.openxmlformats.org/drawingml/2006/chart">
@@ -1943,16 +3079,762 @@
           </a:graphicData>
         </a:graphic>
       </p:graphicFrame>
+      <p:graphicFrame>
+        <p:nvGraphicFramePr>
+          <p:cNvPr id="3" name="tabel-skenario"/>
+          <p:cNvGraphicFramePr>
+            <a:graphicFrameLocks noGrp="1"/>
+          </p:cNvGraphicFramePr>
+          <p:nvPr>
+            <p:extLst>
+              <p:ext uri="{D42A27DB-BD31-4B8C-83A1-F6EECF244321}">
+                <p14:modId xmlns:p14="http://schemas.microsoft.com/office/powerpoint/2010/main" val="1579011935"/>
+              </p:ext>
+            </p:extLst>
+          </p:nvPr>
+        </p:nvGraphicFramePr>
+        <p:xfrm>
+          <a:off x="6035040" y="4709160"/>
+          <a:ext cx="5608015" cy="914400"/>
+        </p:xfrm>
+        <a:graphic>
+          <a:graphicData uri="http://schemas.openxmlformats.org/drawingml/2006/table">
+            <a:tbl>
+              <a:tblPr/>
+              <a:tblGrid>
+                <a:gridCol w="1463040"/>
+                <a:gridCol w="2011680"/>
+                <a:gridCol w="2133295"/>
+              </a:tblGrid>
+              <a:tr h="274320">
+                <a:tc>
+                  <a:txBody>
+                    <a:bodyPr/>
+                    <a:lstStyle/>
+                    <a:p>
+                      <a:pPr algn="l" indent="0" marL="0">
+                        <a:buNone/>
+                      </a:pPr>
+                      <a:r>
+                        <a:rPr lang="en-US" sz="1200" b="1" dirty="0">
+                          <a:solidFill>
+                            <a:srgbClr val="5F6B65"/>
+                          </a:solidFill>
+                          <a:latin typeface="Calibri" pitchFamily="34" charset="0"/>
+                          <a:ea typeface="Calibri" pitchFamily="34" charset="-122"/>
+                          <a:cs typeface="Calibri" pitchFamily="34" charset="-120"/>
+                        </a:rPr>
+                        <a:t>Harga</a:t>
+                      </a:r>
+                      <a:endParaRPr lang="en-US" sz="1200" dirty="0">
+                        <a:latin typeface="Calibri" charset="0"/>
+                        <a:ea typeface="Calibri" charset="0"/>
+                        <a:cs typeface="Calibri" charset="0"/>
+                      </a:endParaRPr>
+                    </a:p>
+                  </a:txBody>
+                  <a:tcPr marL="73152" marR="73152" marT="18288" marB="18288" anchor="ctr">
+                    <a:lnL w="0" cap="flat" cmpd="sng" algn="ctr">
+                      <a:noFill/>
+                    </a:lnL>
+                    <a:lnR w="0" cap="flat" cmpd="sng" algn="ctr">
+                      <a:noFill/>
+                    </a:lnR>
+                    <a:lnT w="0" cap="flat" cmpd="sng" algn="ctr">
+                      <a:noFill/>
+                    </a:lnT>
+                    <a:lnB w="12700" cap="flat" cmpd="sng" algn="ctr">
+                      <a:solidFill>
+                        <a:srgbClr val="D5DBD6"/>
+                      </a:solidFill>
+                      <a:prstDash val="solid"/>
+                      <a:round/>
+                      <a:headEnd type="none" w="med" len="med"/>
+                      <a:tailEnd type="none" w="med" len="med"/>
+                    </a:lnB>
+                  </a:tcPr>
+                </a:tc>
+                <a:tc>
+                  <a:txBody>
+                    <a:bodyPr/>
+                    <a:lstStyle/>
+                    <a:p>
+                      <a:pPr algn="r" indent="0" marL="0">
+                        <a:buNone/>
+                      </a:pPr>
+                      <a:r>
+                        <a:rPr lang="en-US" sz="1200" b="1" dirty="0">
+                          <a:solidFill>
+                            <a:srgbClr val="5F6B65"/>
+                          </a:solidFill>
+                          <a:latin typeface="Calibri" pitchFamily="34" charset="0"/>
+                          <a:ea typeface="Calibri" pitchFamily="34" charset="-122"/>
+                          <a:cs typeface="Calibri" pitchFamily="34" charset="-120"/>
+                        </a:rPr>
+                        <a:t>Porsi LPHD 60% (Rp)</a:t>
+                      </a:r>
+                      <a:endParaRPr lang="en-US" sz="1200" dirty="0">
+                        <a:latin typeface="Calibri" charset="0"/>
+                        <a:ea typeface="Calibri" charset="0"/>
+                        <a:cs typeface="Calibri" charset="0"/>
+                      </a:endParaRPr>
+                    </a:p>
+                  </a:txBody>
+                  <a:tcPr marL="73152" marR="73152" marT="18288" marB="18288" anchor="ctr">
+                    <a:lnL w="0" cap="flat" cmpd="sng" algn="ctr">
+                      <a:noFill/>
+                    </a:lnL>
+                    <a:lnR w="0" cap="flat" cmpd="sng" algn="ctr">
+                      <a:noFill/>
+                    </a:lnR>
+                    <a:lnT w="0" cap="flat" cmpd="sng" algn="ctr">
+                      <a:noFill/>
+                    </a:lnT>
+                    <a:lnB w="12700" cap="flat" cmpd="sng" algn="ctr">
+                      <a:solidFill>
+                        <a:srgbClr val="D5DBD6"/>
+                      </a:solidFill>
+                      <a:prstDash val="solid"/>
+                      <a:round/>
+                      <a:headEnd type="none" w="med" len="med"/>
+                      <a:tailEnd type="none" w="med" len="med"/>
+                    </a:lnB>
+                  </a:tcPr>
+                </a:tc>
+                <a:tc>
+                  <a:txBody>
+                    <a:bodyPr/>
+                    <a:lstStyle/>
+                    <a:p>
+                      <a:pPr algn="r" indent="0" marL="0">
+                        <a:buNone/>
+                      </a:pPr>
+                      <a:r>
+                        <a:rPr lang="en-US" sz="1200" b="1" dirty="0">
+                          <a:solidFill>
+                            <a:srgbClr val="5F6B65"/>
+                          </a:solidFill>
+                          <a:latin typeface="Calibri" pitchFamily="34" charset="0"/>
+                          <a:ea typeface="Calibri" pitchFamily="34" charset="-122"/>
+                          <a:cs typeface="Calibri" pitchFamily="34" charset="-120"/>
+                        </a:rPr>
+                        <a:t>Keseluruhan 100% (Rp)</a:t>
+                      </a:r>
+                      <a:endParaRPr lang="en-US" sz="1200" dirty="0">
+                        <a:latin typeface="Calibri" charset="0"/>
+                        <a:ea typeface="Calibri" charset="0"/>
+                        <a:cs typeface="Calibri" charset="0"/>
+                      </a:endParaRPr>
+                    </a:p>
+                  </a:txBody>
+                  <a:tcPr marL="73152" marR="73152" marT="18288" marB="18288" anchor="ctr">
+                    <a:lnL w="0" cap="flat" cmpd="sng" algn="ctr">
+                      <a:noFill/>
+                    </a:lnL>
+                    <a:lnR w="0" cap="flat" cmpd="sng" algn="ctr">
+                      <a:noFill/>
+                    </a:lnR>
+                    <a:lnT w="0" cap="flat" cmpd="sng" algn="ctr">
+                      <a:noFill/>
+                    </a:lnT>
+                    <a:lnB w="12700" cap="flat" cmpd="sng" algn="ctr">
+                      <a:solidFill>
+                        <a:srgbClr val="D5DBD6"/>
+                      </a:solidFill>
+                      <a:prstDash val="solid"/>
+                      <a:round/>
+                      <a:headEnd type="none" w="med" len="med"/>
+                      <a:tailEnd type="none" w="med" len="med"/>
+                    </a:lnB>
+                  </a:tcPr>
+                </a:tc>
+              </a:tr>
+              <a:tr h="274320">
+                <a:tc>
+                  <a:txBody>
+                    <a:bodyPr/>
+                    <a:lstStyle/>
+                    <a:p>
+                      <a:pPr algn="l" indent="0" marL="0">
+                        <a:buNone/>
+                      </a:pPr>
+                      <a:r>
+                        <a:rPr lang="en-US" sz="1200" dirty="0">
+                          <a:solidFill>
+                            <a:srgbClr val="1B2420"/>
+                          </a:solidFill>
+                          <a:latin typeface="Calibri" pitchFamily="34" charset="0"/>
+                          <a:ea typeface="Calibri" pitchFamily="34" charset="-122"/>
+                          <a:cs typeface="Calibri" pitchFamily="34" charset="-120"/>
+                        </a:rPr>
+                        <a:t>20 USD/VCU</a:t>
+                      </a:r>
+                      <a:endParaRPr lang="en-US" sz="1200" dirty="0">
+                        <a:latin typeface="Calibri" charset="0"/>
+                        <a:ea typeface="Calibri" charset="0"/>
+                        <a:cs typeface="Calibri" charset="0"/>
+                      </a:endParaRPr>
+                    </a:p>
+                  </a:txBody>
+                  <a:tcPr marL="73152" marR="73152" marT="18288" marB="18288" anchor="ctr">
+                    <a:lnL w="0" cap="flat" cmpd="sng" algn="ctr">
+                      <a:noFill/>
+                    </a:lnL>
+                    <a:lnR w="0" cap="flat" cmpd="sng" algn="ctr">
+                      <a:noFill/>
+                    </a:lnR>
+                    <a:lnT w="0" cap="flat" cmpd="sng" algn="ctr">
+                      <a:noFill/>
+                    </a:lnT>
+                    <a:lnB w="9525" cap="flat" cmpd="sng" algn="ctr">
+                      <a:solidFill>
+                        <a:srgbClr val="D5DBD6"/>
+                      </a:solidFill>
+                      <a:prstDash val="solid"/>
+                      <a:round/>
+                      <a:headEnd type="none" w="med" len="med"/>
+                      <a:tailEnd type="none" w="med" len="med"/>
+                    </a:lnB>
+                  </a:tcPr>
+                </a:tc>
+                <a:tc>
+                  <a:txBody>
+                    <a:bodyPr/>
+                    <a:lstStyle/>
+                    <a:p>
+                      <a:pPr algn="r" indent="0" marL="0">
+                        <a:buNone/>
+                      </a:pPr>
+                      <a:r>
+                        <a:rPr lang="en-US" sz="1200" b="1" dirty="0">
+                          <a:solidFill>
+                            <a:srgbClr val="1F5A45"/>
+                          </a:solidFill>
+                          <a:latin typeface="Calibri" pitchFamily="34" charset="0"/>
+                          <a:ea typeface="Calibri" pitchFamily="34" charset="-122"/>
+                          <a:cs typeface="Calibri" pitchFamily="34" charset="-120"/>
+                        </a:rPr>
+                        <a:t>2.118.404.234</a:t>
+                      </a:r>
+                      <a:endParaRPr lang="en-US" sz="1200" dirty="0">
+                        <a:latin typeface="Calibri" charset="0"/>
+                        <a:ea typeface="Calibri" charset="0"/>
+                        <a:cs typeface="Calibri" charset="0"/>
+                      </a:endParaRPr>
+                    </a:p>
+                  </a:txBody>
+                  <a:tcPr marL="73152" marR="73152" marT="18288" marB="18288" anchor="ctr">
+                    <a:lnL w="0" cap="flat" cmpd="sng" algn="ctr">
+                      <a:noFill/>
+                    </a:lnL>
+                    <a:lnR w="0" cap="flat" cmpd="sng" algn="ctr">
+                      <a:noFill/>
+                    </a:lnR>
+                    <a:lnT w="0" cap="flat" cmpd="sng" algn="ctr">
+                      <a:noFill/>
+                    </a:lnT>
+                    <a:lnB w="9525" cap="flat" cmpd="sng" algn="ctr">
+                      <a:solidFill>
+                        <a:srgbClr val="D5DBD6"/>
+                      </a:solidFill>
+                      <a:prstDash val="solid"/>
+                      <a:round/>
+                      <a:headEnd type="none" w="med" len="med"/>
+                      <a:tailEnd type="none" w="med" len="med"/>
+                    </a:lnB>
+                  </a:tcPr>
+                </a:tc>
+                <a:tc>
+                  <a:txBody>
+                    <a:bodyPr/>
+                    <a:lstStyle/>
+                    <a:p>
+                      <a:pPr algn="r" indent="0" marL="0">
+                        <a:buNone/>
+                      </a:pPr>
+                      <a:r>
+                        <a:rPr lang="en-US" sz="1200" dirty="0">
+                          <a:solidFill>
+                            <a:srgbClr val="1B2420"/>
+                          </a:solidFill>
+                          <a:latin typeface="Calibri" pitchFamily="34" charset="0"/>
+                          <a:ea typeface="Calibri" pitchFamily="34" charset="-122"/>
+                          <a:cs typeface="Calibri" pitchFamily="34" charset="-120"/>
+                        </a:rPr>
+                        <a:t>3.530.673.724</a:t>
+                      </a:r>
+                      <a:endParaRPr lang="en-US" sz="1200" dirty="0">
+                        <a:latin typeface="Calibri" charset="0"/>
+                        <a:ea typeface="Calibri" charset="0"/>
+                        <a:cs typeface="Calibri" charset="0"/>
+                      </a:endParaRPr>
+                    </a:p>
+                  </a:txBody>
+                  <a:tcPr marL="73152" marR="73152" marT="18288" marB="18288" anchor="ctr">
+                    <a:lnL w="0" cap="flat" cmpd="sng" algn="ctr">
+                      <a:noFill/>
+                    </a:lnL>
+                    <a:lnR w="0" cap="flat" cmpd="sng" algn="ctr">
+                      <a:noFill/>
+                    </a:lnR>
+                    <a:lnT w="0" cap="flat" cmpd="sng" algn="ctr">
+                      <a:noFill/>
+                    </a:lnT>
+                    <a:lnB w="9525" cap="flat" cmpd="sng" algn="ctr">
+                      <a:solidFill>
+                        <a:srgbClr val="D5DBD6"/>
+                      </a:solidFill>
+                      <a:prstDash val="solid"/>
+                      <a:round/>
+                      <a:headEnd type="none" w="med" len="med"/>
+                      <a:tailEnd type="none" w="med" len="med"/>
+                    </a:lnB>
+                  </a:tcPr>
+                </a:tc>
+              </a:tr>
+              <a:tr h="274320">
+                <a:tc>
+                  <a:txBody>
+                    <a:bodyPr/>
+                    <a:lstStyle/>
+                    <a:p>
+                      <a:pPr algn="l" indent="0" marL="0">
+                        <a:buNone/>
+                      </a:pPr>
+                      <a:r>
+                        <a:rPr lang="en-US" sz="1200" dirty="0">
+                          <a:solidFill>
+                            <a:srgbClr val="1B2420"/>
+                          </a:solidFill>
+                          <a:latin typeface="Calibri" pitchFamily="34" charset="0"/>
+                          <a:ea typeface="Calibri" pitchFamily="34" charset="-122"/>
+                          <a:cs typeface="Calibri" pitchFamily="34" charset="-120"/>
+                        </a:rPr>
+                        <a:t>15 USD/VCU</a:t>
+                      </a:r>
+                      <a:endParaRPr lang="en-US" sz="1200" dirty="0">
+                        <a:latin typeface="Calibri" charset="0"/>
+                        <a:ea typeface="Calibri" charset="0"/>
+                        <a:cs typeface="Calibri" charset="0"/>
+                      </a:endParaRPr>
+                    </a:p>
+                  </a:txBody>
+                  <a:tcPr marL="73152" marR="73152" marT="18288" marB="18288" anchor="ctr">
+                    <a:lnL w="0" cap="flat" cmpd="sng" algn="ctr">
+                      <a:noFill/>
+                    </a:lnL>
+                    <a:lnR w="0" cap="flat" cmpd="sng" algn="ctr">
+                      <a:noFill/>
+                    </a:lnR>
+                    <a:lnT w="0" cap="flat" cmpd="sng" algn="ctr">
+                      <a:noFill/>
+                    </a:lnT>
+                    <a:lnB w="9525" cap="flat" cmpd="sng" algn="ctr">
+                      <a:solidFill>
+                        <a:srgbClr val="D5DBD6"/>
+                      </a:solidFill>
+                      <a:prstDash val="solid"/>
+                      <a:round/>
+                      <a:headEnd type="none" w="med" len="med"/>
+                      <a:tailEnd type="none" w="med" len="med"/>
+                    </a:lnB>
+                  </a:tcPr>
+                </a:tc>
+                <a:tc>
+                  <a:txBody>
+                    <a:bodyPr/>
+                    <a:lstStyle/>
+                    <a:p>
+                      <a:pPr algn="r" indent="0" marL="0">
+                        <a:buNone/>
+                      </a:pPr>
+                      <a:r>
+                        <a:rPr lang="en-US" sz="1200" b="1" dirty="0">
+                          <a:solidFill>
+                            <a:srgbClr val="1F5A45"/>
+                          </a:solidFill>
+                          <a:latin typeface="Calibri" pitchFamily="34" charset="0"/>
+                          <a:ea typeface="Calibri" pitchFamily="34" charset="-122"/>
+                          <a:cs typeface="Calibri" pitchFamily="34" charset="-120"/>
+                        </a:rPr>
+                        <a:t>1.588.803.176</a:t>
+                      </a:r>
+                      <a:endParaRPr lang="en-US" sz="1200" dirty="0">
+                        <a:latin typeface="Calibri" charset="0"/>
+                        <a:ea typeface="Calibri" charset="0"/>
+                        <a:cs typeface="Calibri" charset="0"/>
+                      </a:endParaRPr>
+                    </a:p>
+                  </a:txBody>
+                  <a:tcPr marL="73152" marR="73152" marT="18288" marB="18288" anchor="ctr">
+                    <a:lnL w="0" cap="flat" cmpd="sng" algn="ctr">
+                      <a:noFill/>
+                    </a:lnL>
+                    <a:lnR w="0" cap="flat" cmpd="sng" algn="ctr">
+                      <a:noFill/>
+                    </a:lnR>
+                    <a:lnT w="0" cap="flat" cmpd="sng" algn="ctr">
+                      <a:noFill/>
+                    </a:lnT>
+                    <a:lnB w="9525" cap="flat" cmpd="sng" algn="ctr">
+                      <a:solidFill>
+                        <a:srgbClr val="D5DBD6"/>
+                      </a:solidFill>
+                      <a:prstDash val="solid"/>
+                      <a:round/>
+                      <a:headEnd type="none" w="med" len="med"/>
+                      <a:tailEnd type="none" w="med" len="med"/>
+                    </a:lnB>
+                  </a:tcPr>
+                </a:tc>
+                <a:tc>
+                  <a:txBody>
+                    <a:bodyPr/>
+                    <a:lstStyle/>
+                    <a:p>
+                      <a:pPr algn="r" indent="0" marL="0">
+                        <a:buNone/>
+                      </a:pPr>
+                      <a:r>
+                        <a:rPr lang="en-US" sz="1200" dirty="0">
+                          <a:solidFill>
+                            <a:srgbClr val="1B2420"/>
+                          </a:solidFill>
+                          <a:latin typeface="Calibri" pitchFamily="34" charset="0"/>
+                          <a:ea typeface="Calibri" pitchFamily="34" charset="-122"/>
+                          <a:cs typeface="Calibri" pitchFamily="34" charset="-120"/>
+                        </a:rPr>
+                        <a:t>2.648.005.293</a:t>
+                      </a:r>
+                      <a:endParaRPr lang="en-US" sz="1200" dirty="0">
+                        <a:latin typeface="Calibri" charset="0"/>
+                        <a:ea typeface="Calibri" charset="0"/>
+                        <a:cs typeface="Calibri" charset="0"/>
+                      </a:endParaRPr>
+                    </a:p>
+                  </a:txBody>
+                  <a:tcPr marL="73152" marR="73152" marT="18288" marB="18288" anchor="ctr">
+                    <a:lnL w="0" cap="flat" cmpd="sng" algn="ctr">
+                      <a:noFill/>
+                    </a:lnL>
+                    <a:lnR w="0" cap="flat" cmpd="sng" algn="ctr">
+                      <a:noFill/>
+                    </a:lnR>
+                    <a:lnT w="0" cap="flat" cmpd="sng" algn="ctr">
+                      <a:noFill/>
+                    </a:lnT>
+                    <a:lnB w="9525" cap="flat" cmpd="sng" algn="ctr">
+                      <a:solidFill>
+                        <a:srgbClr val="D5DBD6"/>
+                      </a:solidFill>
+                      <a:prstDash val="solid"/>
+                      <a:round/>
+                      <a:headEnd type="none" w="med" len="med"/>
+                      <a:tailEnd type="none" w="med" len="med"/>
+                    </a:lnB>
+                  </a:tcPr>
+                </a:tc>
+              </a:tr>
+              <a:tr h="274320">
+                <a:tc>
+                  <a:txBody>
+                    <a:bodyPr/>
+                    <a:lstStyle/>
+                    <a:p>
+                      <a:pPr algn="l" indent="0" marL="0">
+                        <a:buNone/>
+                      </a:pPr>
+                      <a:r>
+                        <a:rPr lang="en-US" sz="1200" dirty="0">
+                          <a:solidFill>
+                            <a:srgbClr val="1B2420"/>
+                          </a:solidFill>
+                          <a:latin typeface="Calibri" pitchFamily="34" charset="0"/>
+                          <a:ea typeface="Calibri" pitchFamily="34" charset="-122"/>
+                          <a:cs typeface="Calibri" pitchFamily="34" charset="-120"/>
+                        </a:rPr>
+                        <a:t>10 USD/VCU</a:t>
+                      </a:r>
+                      <a:endParaRPr lang="en-US" sz="1200" dirty="0">
+                        <a:latin typeface="Calibri" charset="0"/>
+                        <a:ea typeface="Calibri" charset="0"/>
+                        <a:cs typeface="Calibri" charset="0"/>
+                      </a:endParaRPr>
+                    </a:p>
+                  </a:txBody>
+                  <a:tcPr marL="73152" marR="73152" marT="18288" marB="18288" anchor="ctr">
+                    <a:lnL w="0" cap="flat" cmpd="sng" algn="ctr">
+                      <a:noFill/>
+                    </a:lnL>
+                    <a:lnR w="0" cap="flat" cmpd="sng" algn="ctr">
+                      <a:noFill/>
+                    </a:lnR>
+                    <a:lnT w="0" cap="flat" cmpd="sng" algn="ctr">
+                      <a:noFill/>
+                    </a:lnT>
+                    <a:lnB w="9525" cap="flat" cmpd="sng" algn="ctr">
+                      <a:solidFill>
+                        <a:srgbClr val="D5DBD6"/>
+                      </a:solidFill>
+                      <a:prstDash val="solid"/>
+                      <a:round/>
+                      <a:headEnd type="none" w="med" len="med"/>
+                      <a:tailEnd type="none" w="med" len="med"/>
+                    </a:lnB>
+                  </a:tcPr>
+                </a:tc>
+                <a:tc>
+                  <a:txBody>
+                    <a:bodyPr/>
+                    <a:lstStyle/>
+                    <a:p>
+                      <a:pPr algn="r" indent="0" marL="0">
+                        <a:buNone/>
+                      </a:pPr>
+                      <a:r>
+                        <a:rPr lang="en-US" sz="1200" b="1" dirty="0">
+                          <a:solidFill>
+                            <a:srgbClr val="1F5A45"/>
+                          </a:solidFill>
+                          <a:latin typeface="Calibri" pitchFamily="34" charset="0"/>
+                          <a:ea typeface="Calibri" pitchFamily="34" charset="-122"/>
+                          <a:cs typeface="Calibri" pitchFamily="34" charset="-120"/>
+                        </a:rPr>
+                        <a:t>1.059.202.117</a:t>
+                      </a:r>
+                      <a:endParaRPr lang="en-US" sz="1200" dirty="0">
+                        <a:latin typeface="Calibri" charset="0"/>
+                        <a:ea typeface="Calibri" charset="0"/>
+                        <a:cs typeface="Calibri" charset="0"/>
+                      </a:endParaRPr>
+                    </a:p>
+                  </a:txBody>
+                  <a:tcPr marL="73152" marR="73152" marT="18288" marB="18288" anchor="ctr">
+                    <a:lnL w="0" cap="flat" cmpd="sng" algn="ctr">
+                      <a:noFill/>
+                    </a:lnL>
+                    <a:lnR w="0" cap="flat" cmpd="sng" algn="ctr">
+                      <a:noFill/>
+                    </a:lnR>
+                    <a:lnT w="0" cap="flat" cmpd="sng" algn="ctr">
+                      <a:noFill/>
+                    </a:lnT>
+                    <a:lnB w="9525" cap="flat" cmpd="sng" algn="ctr">
+                      <a:solidFill>
+                        <a:srgbClr val="D5DBD6"/>
+                      </a:solidFill>
+                      <a:prstDash val="solid"/>
+                      <a:round/>
+                      <a:headEnd type="none" w="med" len="med"/>
+                      <a:tailEnd type="none" w="med" len="med"/>
+                    </a:lnB>
+                  </a:tcPr>
+                </a:tc>
+                <a:tc>
+                  <a:txBody>
+                    <a:bodyPr/>
+                    <a:lstStyle/>
+                    <a:p>
+                      <a:pPr algn="r" indent="0" marL="0">
+                        <a:buNone/>
+                      </a:pPr>
+                      <a:r>
+                        <a:rPr lang="en-US" sz="1200" dirty="0">
+                          <a:solidFill>
+                            <a:srgbClr val="1B2420"/>
+                          </a:solidFill>
+                          <a:latin typeface="Calibri" pitchFamily="34" charset="0"/>
+                          <a:ea typeface="Calibri" pitchFamily="34" charset="-122"/>
+                          <a:cs typeface="Calibri" pitchFamily="34" charset="-120"/>
+                        </a:rPr>
+                        <a:t>1.765.336.862</a:t>
+                      </a:r>
+                      <a:endParaRPr lang="en-US" sz="1200" dirty="0">
+                        <a:latin typeface="Calibri" charset="0"/>
+                        <a:ea typeface="Calibri" charset="0"/>
+                        <a:cs typeface="Calibri" charset="0"/>
+                      </a:endParaRPr>
+                    </a:p>
+                  </a:txBody>
+                  <a:tcPr marL="73152" marR="73152" marT="18288" marB="18288" anchor="ctr">
+                    <a:lnL w="0" cap="flat" cmpd="sng" algn="ctr">
+                      <a:noFill/>
+                    </a:lnL>
+                    <a:lnR w="0" cap="flat" cmpd="sng" algn="ctr">
+                      <a:noFill/>
+                    </a:lnR>
+                    <a:lnT w="0" cap="flat" cmpd="sng" algn="ctr">
+                      <a:noFill/>
+                    </a:lnT>
+                    <a:lnB w="9525" cap="flat" cmpd="sng" algn="ctr">
+                      <a:solidFill>
+                        <a:srgbClr val="D5DBD6"/>
+                      </a:solidFill>
+                      <a:prstDash val="solid"/>
+                      <a:round/>
+                      <a:headEnd type="none" w="med" len="med"/>
+                      <a:tailEnd type="none" w="med" len="med"/>
+                    </a:lnB>
+                  </a:tcPr>
+                </a:tc>
+              </a:tr>
+              <a:tr h="274320">
+                <a:tc>
+                  <a:txBody>
+                    <a:bodyPr/>
+                    <a:lstStyle/>
+                    <a:p>
+                      <a:pPr algn="l" indent="0" marL="0">
+                        <a:buNone/>
+                      </a:pPr>
+                      <a:r>
+                        <a:rPr lang="en-US" sz="1200" dirty="0">
+                          <a:solidFill>
+                            <a:srgbClr val="1B2420"/>
+                          </a:solidFill>
+                          <a:latin typeface="Calibri" pitchFamily="34" charset="0"/>
+                          <a:ea typeface="Calibri" pitchFamily="34" charset="-122"/>
+                          <a:cs typeface="Calibri" pitchFamily="34" charset="-120"/>
+                        </a:rPr>
+                        <a:t>5 USD/VCU</a:t>
+                      </a:r>
+                      <a:endParaRPr lang="en-US" sz="1200" dirty="0">
+                        <a:latin typeface="Calibri" charset="0"/>
+                        <a:ea typeface="Calibri" charset="0"/>
+                        <a:cs typeface="Calibri" charset="0"/>
+                      </a:endParaRPr>
+                    </a:p>
+                  </a:txBody>
+                  <a:tcPr marL="73152" marR="73152" marT="18288" marB="18288" anchor="ctr">
+                    <a:lnL w="0" cap="flat" cmpd="sng" algn="ctr">
+                      <a:noFill/>
+                    </a:lnL>
+                    <a:lnR w="0" cap="flat" cmpd="sng" algn="ctr">
+                      <a:noFill/>
+                    </a:lnR>
+                    <a:lnT w="0" cap="flat" cmpd="sng" algn="ctr">
+                      <a:noFill/>
+                    </a:lnT>
+                    <a:lnB w="9525" cap="flat" cmpd="sng" algn="ctr">
+                      <a:solidFill>
+                        <a:srgbClr val="D5DBD6"/>
+                      </a:solidFill>
+                      <a:prstDash val="solid"/>
+                      <a:round/>
+                      <a:headEnd type="none" w="med" len="med"/>
+                      <a:tailEnd type="none" w="med" len="med"/>
+                    </a:lnB>
+                  </a:tcPr>
+                </a:tc>
+                <a:tc>
+                  <a:txBody>
+                    <a:bodyPr/>
+                    <a:lstStyle/>
+                    <a:p>
+                      <a:pPr algn="r" indent="0" marL="0">
+                        <a:buNone/>
+                      </a:pPr>
+                      <a:r>
+                        <a:rPr lang="en-US" sz="1200" b="1" dirty="0">
+                          <a:solidFill>
+                            <a:srgbClr val="1F5A45"/>
+                          </a:solidFill>
+                          <a:latin typeface="Calibri" pitchFamily="34" charset="0"/>
+                          <a:ea typeface="Calibri" pitchFamily="34" charset="-122"/>
+                          <a:cs typeface="Calibri" pitchFamily="34" charset="-120"/>
+                        </a:rPr>
+                        <a:t>529.601.059</a:t>
+                      </a:r>
+                      <a:endParaRPr lang="en-US" sz="1200" dirty="0">
+                        <a:latin typeface="Calibri" charset="0"/>
+                        <a:ea typeface="Calibri" charset="0"/>
+                        <a:cs typeface="Calibri" charset="0"/>
+                      </a:endParaRPr>
+                    </a:p>
+                  </a:txBody>
+                  <a:tcPr marL="73152" marR="73152" marT="18288" marB="18288" anchor="ctr">
+                    <a:lnL w="0" cap="flat" cmpd="sng" algn="ctr">
+                      <a:noFill/>
+                    </a:lnL>
+                    <a:lnR w="0" cap="flat" cmpd="sng" algn="ctr">
+                      <a:noFill/>
+                    </a:lnR>
+                    <a:lnT w="0" cap="flat" cmpd="sng" algn="ctr">
+                      <a:noFill/>
+                    </a:lnT>
+                    <a:lnB w="9525" cap="flat" cmpd="sng" algn="ctr">
+                      <a:solidFill>
+                        <a:srgbClr val="D5DBD6"/>
+                      </a:solidFill>
+                      <a:prstDash val="solid"/>
+                      <a:round/>
+                      <a:headEnd type="none" w="med" len="med"/>
+                      <a:tailEnd type="none" w="med" len="med"/>
+                    </a:lnB>
+                  </a:tcPr>
+                </a:tc>
+                <a:tc>
+                  <a:txBody>
+                    <a:bodyPr/>
+                    <a:lstStyle/>
+                    <a:p>
+                      <a:pPr algn="r" indent="0" marL="0">
+                        <a:buNone/>
+                      </a:pPr>
+                      <a:r>
+                        <a:rPr lang="en-US" sz="1200" dirty="0">
+                          <a:solidFill>
+                            <a:srgbClr val="1B2420"/>
+                          </a:solidFill>
+                          <a:latin typeface="Calibri" pitchFamily="34" charset="0"/>
+                          <a:ea typeface="Calibri" pitchFamily="34" charset="-122"/>
+                          <a:cs typeface="Calibri" pitchFamily="34" charset="-120"/>
+                        </a:rPr>
+                        <a:t>882.668.431</a:t>
+                      </a:r>
+                      <a:endParaRPr lang="en-US" sz="1200" dirty="0">
+                        <a:latin typeface="Calibri" charset="0"/>
+                        <a:ea typeface="Calibri" charset="0"/>
+                        <a:cs typeface="Calibri" charset="0"/>
+                      </a:endParaRPr>
+                    </a:p>
+                  </a:txBody>
+                  <a:tcPr marL="73152" marR="73152" marT="18288" marB="18288" anchor="ctr">
+                    <a:lnL w="0" cap="flat" cmpd="sng" algn="ctr">
+                      <a:noFill/>
+                    </a:lnL>
+                    <a:lnR w="0" cap="flat" cmpd="sng" algn="ctr">
+                      <a:noFill/>
+                    </a:lnR>
+                    <a:lnT w="0" cap="flat" cmpd="sng" algn="ctr">
+                      <a:noFill/>
+                    </a:lnT>
+                    <a:lnB w="9525" cap="flat" cmpd="sng" algn="ctr">
+                      <a:solidFill>
+                        <a:srgbClr val="D5DBD6"/>
+                      </a:solidFill>
+                      <a:prstDash val="solid"/>
+                      <a:round/>
+                      <a:headEnd type="none" w="med" len="med"/>
+                      <a:tailEnd type="none" w="med" len="med"/>
+                    </a:lnB>
+                  </a:tcPr>
+                </a:tc>
+              </a:tr>
+            </a:tbl>
+          </a:graphicData>
+        </a:graphic>
+      </p:graphicFrame>
       <p:sp>
         <p:nvSpPr>
-          <p:cNvPr id="20" name="Text 16"/>
+          <p:cNvPr id="14" name="Text 8"/>
           <p:cNvSpPr txBox="1"/>
           <p:nvPr/>
         </p:nvSpPr>
         <p:spPr>
           <a:xfrm>
-            <a:off x="5029200" y="6144768"/>
-            <a:ext cx="6613855" cy="256032"/>
+            <a:off x="6035040" y="6217920"/>
+            <a:ext cx="5608015" cy="219456"/>
           </a:xfrm>
           <a:prstGeom prst="rect">
             <a:avLst/>
@@ -1973,7 +3855,7 @@
                   <a:schemeClr val="accent4"/>
                 </a:solidFill>
               </a:rPr>
-              <a:t>Kurs tersirat ±Rp18.000/USD. Sumber: perhitungan stok karbon LPHD (AGB, BGB, serasah, tanah, tuplah).</a:t>
+              <a:t>Kurs tersirat ±Rp18.000/USD. Sumber: perhitungan stok karbon LPHD.</a:t>
             </a:r>
             <a:endParaRPr lang="en-US" sz="1000" dirty="0"/>
           </a:p>

</xml_diff>